<commit_message>
Add dashboard slides to the presentation
</commit_message>
<xml_diff>
--- a/presentation/Movie_Recommendation_Presentation.pptx
+++ b/presentation/Movie_Recommendation_Presentation.pptx
@@ -26,9 +26,11 @@
     <p:sldId id="274" r:id="rId20"/>
     <p:sldId id="275" r:id="rId21"/>
     <p:sldId id="276" r:id="rId22"/>
+    <p:sldId id="277" r:id="rId23"/>
+    <p:sldId id="278" r:id="rId24"/>
   </p:sldIdLst>
   <p:notesMasterIdLst>
-    <p:notesMasterId r:id="rId23"/>
+    <p:notesMasterId r:id="rId25"/>
   </p:notesMasterIdLst>
   <p:sldSz cx="12192000" cy="6858000"/>
   <p:notesSz cx="6858000" cy="12192000"/>
@@ -127,32 +129,32 @@
   <p:extLst>
     <p:ext uri="{521415D9-36F7-43E2-AB2F-B90AF26B5E84}">
       <p14:sectionLst xmlns:p14="http://schemas.microsoft.com/office/powerpoint/2010/main">
-        <p14:section name="Introduction" id="{0fd54dcc-e41b-754b-09e4-26de5601cacb}">
+        <p14:section name="Introduction" id="{34a94099-5ebb-65d9-1453-60f778326e04}">
           <p14:sldIdLst>
             <p14:sldId id="256"/>
             <p14:sldId id="257"/>
             <p14:sldId id="258"/>
           </p14:sldIdLst>
         </p14:section>
-        <p14:section name="Design" id="{c487268a-a0f2-be92-cadc-f1c1b877b41f}">
+        <p14:section name="Design" id="{b6697132-3d4a-30c2-8bcf-48c21f7e63c6}">
           <p14:sldIdLst>
             <p14:sldId id="259"/>
             <p14:sldId id="260"/>
           </p14:sldIdLst>
         </p14:section>
-        <p14:section name="Data processing" id="{c65d7e87-e448-59ff-f90b-ccb0c89d3482}">
+        <p14:section name="Data processing" id="{6e14b1e5-da34-f717-0a75-4e4d2b4b6032}">
           <p14:sldIdLst>
             <p14:sldId id="261"/>
           </p14:sldIdLst>
         </p14:section>
-        <p14:section name="Graph analysis" id="{69810e62-97e4-5887-f542-ff9844b0bae1}">
+        <p14:section name="Graph analysis" id="{bc7f71de-ef71-426e-b7e6-4fe5fa9a878f}">
           <p14:sldIdLst>
             <p14:sldId id="262"/>
             <p14:sldId id="263"/>
             <p14:sldId id="264"/>
           </p14:sldIdLst>
         </p14:section>
-        <p14:section name="Machine learning" id="{15235cdb-4a5a-ab3f-5626-bffea4f9f44e}">
+        <p14:section name="Machine learning" id="{0e92e8b0-1298-a993-3c36-ffa7665efb2a}">
           <p14:sldIdLst>
             <p14:sldId id="265"/>
             <p14:sldId id="266"/>
@@ -160,7 +162,7 @@
             <p14:sldId id="268"/>
           </p14:sldIdLst>
         </p14:section>
-        <p14:section name="Evaluation" id="{1b50ce62-0779-4346-5fba-f27c8b3862ee}">
+        <p14:section name="Evaluation" id="{9a095fac-78dc-1dfd-6240-e1a2e21be8e6}">
           <p14:sldIdLst>
             <p14:sldId id="269"/>
             <p14:sldId id="270"/>
@@ -168,12 +170,14 @@
             <p14:sldId id="272"/>
             <p14:sldId id="273"/>
             <p14:sldId id="274"/>
+            <p14:sldId id="275"/>
+            <p14:sldId id="276"/>
           </p14:sldIdLst>
         </p14:section>
-        <p14:section name="Conclusion" id="{fc3dbdcc-9933-4dc5-b85d-71bf29847728}">
+        <p14:section name="Conclusion" id="{28756975-7f5c-6107-1361-7c07d6e82147}">
           <p14:sldIdLst>
-            <p14:sldId id="275"/>
-            <p14:sldId id="276"/>
+            <p14:sldId id="277"/>
+            <p14:sldId id="278"/>
           </p14:sldIdLst>
         </p14:section>
       </p14:sectionLst>
@@ -4662,7 +4666,7 @@
           <a:p>
             <a:r>
               <a:rPr lang="en-US" dirty="0"/>
-              <a:t>Left: the full workload on 1, 2, 4 and 8 cores. ALS training scales well, from 12.5 to 5.2 seconds. The graph stage doesn't, because on a small graph the cost of coordinating cores outweighs the work. Overall, 2 cores is fastest for this small dataset. Right: training on more data steadily lowers the error, while training time stays about 4 seconds, since Spark's fixed overhead dominates at this size.</a:t>
+              <a:t>The results are also available as a live web dashboard built with Streamlit and hosted on Render. It reads the saved pipeline results, so the server doesn't need Spark or Java. Recommendations for all 610 users are precomputed by export_dashboard_data.py using the tuned Model B. Open the link during the presentation and pick a user ID to show recommendations live. The free server can take about a minute to wake up, so open it before you start.</a:t>
             </a:r>
             <a:endParaRPr lang="en-US" dirty="0"/>
           </a:p>
@@ -4750,7 +4754,7 @@
           <a:p>
             <a:r>
               <a:rPr lang="en-US" dirty="0"/>
-              <a:t>The full pipeline takes about 7.8 minutes on a 12-core laptop. Most of it is Model B tuning, which trains and ranks 8 ALS models. Training a single ALS model takes under 5 seconds. Every stage is timed automatically and saved in metrics.json.</a:t>
+              <a:t>Left: the Recommend tab. Choose any user to see their favourite movies next to Model B's top-10 recommendations. Right: the Graph insights tab with PageRank, communities and movies liked together, all interactive with hover details.</a:t>
             </a:r>
             <a:endParaRPr lang="en-US" dirty="0"/>
           </a:p>
@@ -4838,7 +4842,7 @@
           <a:p>
             <a:r>
               <a:rPr lang="en-US" dirty="0"/>
-              <a:t>verify.py checks the results automatically and prints PASS or FAIL for each check. The key idea: Spark's numbers are recounted with plain pandas, which doesn't use Spark. It also checks that the models beat their baselines and that recommendations never include already-rated or rarely-rated movies. All 29 checks pass.</a:t>
+              <a:t>Left: the full workload on 1, 2, 4 and 8 cores. ALS training scales well, from 12.5 to 5.2 seconds. The graph stage doesn't, because on a small graph the cost of coordinating cores outweighs the work. Overall, 2 cores is fastest for this small dataset. Right: training on more data steadily lowers the error, while training time stays about 4 seconds, since Spark's fixed overhead dominates at this size.</a:t>
             </a:r>
             <a:endParaRPr lang="en-US" dirty="0"/>
           </a:p>
@@ -5014,7 +5018,7 @@
           <a:p>
             <a:r>
               <a:rPr lang="en-US" dirty="0"/>
-              <a:t>These are the real problems found while building the system and how each was solved. Each one is a good talking point if asked what you learned.</a:t>
+              <a:t>The full pipeline takes about 7.8 minutes on a 12-core laptop. Most of it is Model B tuning, which trains and ranks 8 ALS models. Training a single ALS model takes under 5 seconds. Every stage is timed automatically and saved in metrics.json.</a:t>
             </a:r>
             <a:endParaRPr lang="en-US" dirty="0"/>
           </a:p>
@@ -5102,7 +5106,7 @@
           <a:p>
             <a:r>
               <a:rPr lang="en-US" dirty="0"/>
-              <a:t>Summarise: all five tasks were delivered on Spark, the models beat their baselines, and the results were verified automatically. Future work focuses on a real cluster, a larger dataset and handling new users. Then invite questions.</a:t>
+              <a:t>verify.py checks the results automatically and prints PASS or FAIL for each check. The key idea: Spark's numbers are recounted with plain pandas, which doesn't use Spark. It also checks that the models beat their baselines and that recommendations never include already-rated or rarely-rated movies. All 29 checks pass.</a:t>
             </a:r>
             <a:endParaRPr lang="en-US" dirty="0"/>
           </a:p>
@@ -5126,6 +5130,182 @@
             <a:fld id="{F7021451-1387-4CA6-816F-3879F97B5CBC}" type="slidenum">
               <a:rPr lang="en-US"/>
               <a:t>21</a:t>
+            </a:fld>
+            <a:endParaRPr lang="en-US"/>
+          </a:p>
+        </p:txBody>
+      </p:sp>
+    </p:spTree>
+    <p:extLst>
+      <p:ext uri="{BB962C8B-B14F-4D97-AF65-F5344CB8AC3E}">
+        <p14:creationId xmlns:p14="http://schemas.microsoft.com/office/powerpoint/2010/main" val="1024086991"/>
+      </p:ext>
+    </p:extLst>
+  </p:cSld>
+  <p:clrMapOvr>
+    <a:masterClrMapping/>
+  </p:clrMapOvr>
+</p:notes>
+</file>
+
+<file path=ppt/notesSlides/notesSlide22.xml><?xml version="1.0" encoding="utf-8"?>
+<p:notes xmlns:a="http://schemas.openxmlformats.org/drawingml/2006/main" xmlns:r="http://schemas.openxmlformats.org/officeDocument/2006/relationships" xmlns:p="http://schemas.openxmlformats.org/presentationml/2006/main">
+  <p:cSld>
+    <p:spTree>
+      <p:nvGrpSpPr>
+        <p:cNvPr id="1" name=""/>
+        <p:cNvGrpSpPr/>
+        <p:nvPr/>
+      </p:nvGrpSpPr>
+      <p:grpSpPr>
+        <a:xfrm>
+          <a:off x="0" y="0"/>
+          <a:ext cx="0" cy="0"/>
+          <a:chOff x="0" y="0"/>
+          <a:chExt cx="0" cy="0"/>
+        </a:xfrm>
+      </p:grpSpPr>
+      <p:sp>
+        <p:nvSpPr>
+          <p:cNvPr id="2" name="Slide Image Placeholder 1"/>
+          <p:cNvSpPr>
+            <a:spLocks noGrp="1" noRot="1" noChangeAspect="1"/>
+          </p:cNvSpPr>
+          <p:nvPr>
+            <p:ph type="sldImg"/>
+          </p:nvPr>
+        </p:nvSpPr>
+        <p:spPr/>
+      </p:sp>
+      <p:sp>
+        <p:nvSpPr>
+          <p:cNvPr id="3" name="Notes Placeholder 2"/>
+          <p:cNvSpPr>
+            <a:spLocks noGrp="1"/>
+          </p:cNvSpPr>
+          <p:nvPr>
+            <p:ph type="body" idx="1"/>
+          </p:nvPr>
+        </p:nvSpPr>
+        <p:spPr/>
+        <p:txBody>
+          <a:bodyPr/>
+          <a:lstStyle/>
+          <a:p>
+            <a:r>
+              <a:rPr lang="en-US" dirty="0"/>
+              <a:t>These are the real problems found while building the system and how each was solved. Each one is a good talking point if asked what you learned.</a:t>
+            </a:r>
+            <a:endParaRPr lang="en-US" dirty="0"/>
+          </a:p>
+        </p:txBody>
+      </p:sp>
+      <p:sp>
+        <p:nvSpPr>
+          <p:cNvPr id="4" name="Slide Number Placeholder 3"/>
+          <p:cNvSpPr>
+            <a:spLocks noGrp="1"/>
+          </p:cNvSpPr>
+          <p:nvPr>
+            <p:ph type="sldNum" sz="quarter" idx="10"/>
+          </p:nvPr>
+        </p:nvSpPr>
+        <p:spPr/>
+        <p:txBody>
+          <a:bodyPr/>
+          <a:lstStyle/>
+          <a:p>
+            <a:fld id="{F7021451-1387-4CA6-816F-3879F97B5CBC}" type="slidenum">
+              <a:rPr lang="en-US"/>
+              <a:t>22</a:t>
+            </a:fld>
+            <a:endParaRPr lang="en-US"/>
+          </a:p>
+        </p:txBody>
+      </p:sp>
+    </p:spTree>
+    <p:extLst>
+      <p:ext uri="{BB962C8B-B14F-4D97-AF65-F5344CB8AC3E}">
+        <p14:creationId xmlns:p14="http://schemas.microsoft.com/office/powerpoint/2010/main" val="1024086991"/>
+      </p:ext>
+    </p:extLst>
+  </p:cSld>
+  <p:clrMapOvr>
+    <a:masterClrMapping/>
+  </p:clrMapOvr>
+</p:notes>
+</file>
+
+<file path=ppt/notesSlides/notesSlide23.xml><?xml version="1.0" encoding="utf-8"?>
+<p:notes xmlns:a="http://schemas.openxmlformats.org/drawingml/2006/main" xmlns:r="http://schemas.openxmlformats.org/officeDocument/2006/relationships" xmlns:p="http://schemas.openxmlformats.org/presentationml/2006/main">
+  <p:cSld>
+    <p:spTree>
+      <p:nvGrpSpPr>
+        <p:cNvPr id="1" name=""/>
+        <p:cNvGrpSpPr/>
+        <p:nvPr/>
+      </p:nvGrpSpPr>
+      <p:grpSpPr>
+        <a:xfrm>
+          <a:off x="0" y="0"/>
+          <a:ext cx="0" cy="0"/>
+          <a:chOff x="0" y="0"/>
+          <a:chExt cx="0" cy="0"/>
+        </a:xfrm>
+      </p:grpSpPr>
+      <p:sp>
+        <p:nvSpPr>
+          <p:cNvPr id="2" name="Slide Image Placeholder 1"/>
+          <p:cNvSpPr>
+            <a:spLocks noGrp="1" noRot="1" noChangeAspect="1"/>
+          </p:cNvSpPr>
+          <p:nvPr>
+            <p:ph type="sldImg"/>
+          </p:nvPr>
+        </p:nvSpPr>
+        <p:spPr/>
+      </p:sp>
+      <p:sp>
+        <p:nvSpPr>
+          <p:cNvPr id="3" name="Notes Placeholder 2"/>
+          <p:cNvSpPr>
+            <a:spLocks noGrp="1"/>
+          </p:cNvSpPr>
+          <p:nvPr>
+            <p:ph type="body" idx="1"/>
+          </p:nvPr>
+        </p:nvSpPr>
+        <p:spPr/>
+        <p:txBody>
+          <a:bodyPr/>
+          <a:lstStyle/>
+          <a:p>
+            <a:r>
+              <a:rPr lang="en-US" dirty="0"/>
+              <a:t>Summarise: all five tasks were delivered on Spark, the models beat their baselines, and the results were verified automatically. Future work focuses on a real cluster, a larger dataset and handling new users. Then invite questions.</a:t>
+            </a:r>
+            <a:endParaRPr lang="en-US" dirty="0"/>
+          </a:p>
+        </p:txBody>
+      </p:sp>
+      <p:sp>
+        <p:nvSpPr>
+          <p:cNvPr id="4" name="Slide Number Placeholder 3"/>
+          <p:cNvSpPr>
+            <a:spLocks noGrp="1"/>
+          </p:cNvSpPr>
+          <p:nvPr>
+            <p:ph type="sldNum" sz="quarter" idx="10"/>
+          </p:nvPr>
+        </p:nvSpPr>
+        <p:spPr/>
+        <p:txBody>
+          <a:bodyPr/>
+          <a:lstStyle/>
+          <a:p>
+            <a:fld id="{F7021451-1387-4CA6-816F-3879F97B5CBC}" type="slidenum">
+              <a:rPr lang="en-US"/>
+              <a:t>23</a:t>
             </a:fld>
             <a:endParaRPr lang="en-US"/>
           </a:p>
@@ -12596,58 +12776,86 @@
                   <a:schemeClr val="tx1"/>
                 </a:solidFill>
               </a:rPr>
-              <a:t>Scalability experiments</a:t>
+              <a:t>Live dashboard (Streamlit)</a:t>
             </a:r>
             <a:endParaRPr lang="en-US" sz="3600" dirty="0"/>
           </a:p>
         </p:txBody>
       </p:sp>
-      <p:graphicFrame>
-        <p:nvGraphicFramePr>
-          <p:cNvPr id="4" name="Chart 0" descr=""/>
-          <p:cNvGraphicFramePr/>
-          <p:nvPr/>
-        </p:nvGraphicFramePr>
-        <p:xfrm>
-          <a:off x="548640" y="1325880"/>
-          <a:ext cx="5486400" cy="3886200"/>
-        </p:xfrm>
-        <a:graphic xmlns:a="http://schemas.openxmlformats.org/drawingml/2006/main">
-          <a:graphicData uri="http://schemas.openxmlformats.org/drawingml/2006/chart">
-            <c:chart xmlns:c="http://schemas.openxmlformats.org/drawingml/2006/chart" r:id="rId1"/>
-          </a:graphicData>
-        </a:graphic>
-      </p:graphicFrame>
-      <p:graphicFrame>
-        <p:nvGraphicFramePr>
-          <p:cNvPr id="5" name="Chart 1" descr=""/>
-          <p:cNvGraphicFramePr/>
-          <p:nvPr/>
-        </p:nvGraphicFramePr>
-        <p:xfrm>
-          <a:off x="6126480" y="1325880"/>
-          <a:ext cx="5486400" cy="3886200"/>
-        </p:xfrm>
-        <a:graphic xmlns:a="http://schemas.openxmlformats.org/drawingml/2006/main">
-          <a:graphicData uri="http://schemas.openxmlformats.org/drawingml/2006/chart">
-            <c:chart xmlns:c="http://schemas.openxmlformats.org/drawingml/2006/chart" r:id="rId2"/>
-          </a:graphicData>
-        </a:graphic>
-      </p:graphicFrame>
-      <p:sp>
-        <p:nvSpPr>
-          <p:cNvPr id="6" name="Shape 1"/>
+      <p:pic>
+        <p:nvPicPr>
+          <p:cNvPr id="4" name="Image 0" descr="Dashboard overview tab with key metrics and charts">    </p:cNvPr>
+          <p:cNvPicPr>
+            <a:picLocks noChangeAspect="1"/>
+          </p:cNvPicPr>
+          <p:nvPr/>
+        </p:nvPicPr>
+        <p:blipFill>
+          <a:blip r:embed="rId1"/>
+          <a:stretch>
+            <a:fillRect/>
+          </a:stretch>
+        </p:blipFill>
+        <p:spPr>
+          <a:xfrm>
+            <a:off x="548640" y="1325880"/>
+            <a:ext cx="7040880" cy="4400550"/>
+          </a:xfrm>
+          <a:prstGeom prst="rect">
+            <a:avLst/>
+          </a:prstGeom>
+        </p:spPr>
+      </p:pic>
+      <p:sp>
+        <p:nvSpPr>
+          <p:cNvPr id="5" name="Text 1"/>
+          <p:cNvSpPr txBox="1"/>
+          <p:nvPr/>
+        </p:nvSpPr>
+        <p:spPr>
+          <a:xfrm>
+            <a:off x="548640" y="5817870"/>
+            <a:ext cx="7040880" cy="320040"/>
+          </a:xfrm>
+          <a:prstGeom prst="rect">
+            <a:avLst/>
+          </a:prstGeom>
+          <a:noFill/>
+          <a:ln/>
+        </p:spPr>
+        <p:txBody>
+          <a:bodyPr wrap="square" lIns="0" tIns="0" rIns="0" bIns="0" rtlCol="0" anchor="t"/>
+          <a:lstStyle/>
+          <a:p>
+            <a:pPr indent="0" marL="0">
+              <a:buNone/>
+            </a:pPr>
+            <a:r>
+              <a:rPr lang="en-US" sz="1200" i="1" dirty="0">
+                <a:solidFill>
+                  <a:srgbClr val="555B6E"/>
+                </a:solidFill>
+              </a:rPr>
+              <a:t>Screenshot: Overview tab of the live dashboard</a:t>
+            </a:r>
+            <a:endParaRPr lang="en-US" sz="1200" dirty="0"/>
+          </a:p>
+        </p:txBody>
+      </p:sp>
+      <p:sp>
+        <p:nvSpPr>
+          <p:cNvPr id="6" name="Shape 2"/>
           <p:cNvSpPr/>
           <p:nvPr/>
         </p:nvSpPr>
         <p:spPr>
           <a:xfrm>
-            <a:off x="548640" y="5394960"/>
-            <a:ext cx="3520440" cy="822960"/>
+            <a:off x="7863840" y="1325880"/>
+            <a:ext cx="3749040" cy="4892040"/>
           </a:xfrm>
           <a:prstGeom prst="roundRect">
             <a:avLst>
-              <a:gd name="adj" fmla="val 8889"/>
+              <a:gd name="adj" fmla="val 1951"/>
             </a:avLst>
           </a:prstGeom>
           <a:solidFill>
@@ -12658,14 +12866,14 @@
       </p:sp>
       <p:sp>
         <p:nvSpPr>
-          <p:cNvPr id="7" name="Text 2"/>
+          <p:cNvPr id="7" name="Text 3"/>
           <p:cNvSpPr txBox="1"/>
           <p:nvPr/>
         </p:nvSpPr>
         <p:spPr>
           <a:xfrm>
-            <a:off x="731520" y="5394960"/>
-            <a:ext cx="3154680" cy="822960"/>
+            <a:off x="8092440" y="1508760"/>
+            <a:ext cx="3291840" cy="4572000"/>
           </a:xfrm>
           <a:prstGeom prst="rect">
             <a:avLst/>
@@ -12674,135 +12882,170 @@
           <a:ln/>
         </p:spPr>
         <p:txBody>
-          <a:bodyPr wrap="square" lIns="0" tIns="0" rIns="0" bIns="0" rtlCol="0" anchor="ctr"/>
+          <a:bodyPr wrap="square" lIns="0" tIns="0" rIns="0" bIns="0" rtlCol="0" anchor="t"/>
           <a:lstStyle/>
           <a:p>
             <a:pPr indent="0" marL="0">
+              <a:spcAft>
+                <a:spcPts val="600"/>
+              </a:spcAft>
               <a:buNone/>
             </a:pPr>
             <a:r>
+              <a:rPr lang="en-US" sz="1700" b="1" dirty="0">
+                <a:solidFill>
+                  <a:schemeClr val="tx1"/>
+                </a:solidFill>
+              </a:rPr>
+              <a:t>Open it live</a:t>
+            </a:r>
+            <a:endParaRPr lang="en-US" sz="1400" dirty="0"/>
+          </a:p>
+          <a:p>
+            <a:pPr indent="0" marL="0">
+              <a:spcAft>
+                <a:spcPts val="600"/>
+              </a:spcAft>
+              <a:buNone/>
+            </a:pPr>
+            <a:r>
+              <a:rPr lang="en-US" sz="1200" b="1" u="sng" dirty="0">
+                <a:solidFill>
+                  <a:schemeClr val="accent3"/>
+                </a:solidFill>
+                <a:hlinkClick r:id="rId2" invalidUrl="" action="" tgtFrame="" tooltip="" history="1" highlightClick="0" endSnd="0">
+                  <a:extLst>
+                    <a:ext uri="{A12FA001-AC4F-418D-AE19-62706E023703}">
+                      <ahyp:hlinkClr xmlns:ahyp="http://schemas.microsoft.com/office/drawing/2018/hyperlinkcolor" val="tx"/>
+                    </a:ext>
+                  </a:extLst>
+                </a:hlinkClick>
+              </a:rPr>
+              <a:t>movie-recommendation-spark.onrender.com</a:t>
+            </a:r>
+            <a:endParaRPr lang="en-US" sz="1400" dirty="0"/>
+          </a:p>
+          <a:p>
+            <a:pPr indent="0" marL="0">
+              <a:spcAft>
+                <a:spcPts val="600"/>
+              </a:spcAft>
+              <a:buNone/>
+            </a:pPr>
+            <a:r>
+              <a:rPr lang="en-US" sz="1400" b="1" dirty="0">
+                <a:solidFill>
+                  <a:schemeClr val="tx1"/>
+                </a:solidFill>
+              </a:rPr>
+              <a:t>Five tabs:</a:t>
+            </a:r>
+            <a:endParaRPr lang="en-US" sz="1400" dirty="0"/>
+          </a:p>
+          <a:p>
+            <a:pPr marL="342900" indent="-342900">
+              <a:spcAft>
+                <a:spcPts val="600"/>
+              </a:spcAft>
+              <a:buSzPct val="100000"/>
+              <a:buChar char="•"/>
+            </a:pPr>
+            <a:r>
               <a:rPr lang="en-US" sz="1400" dirty="0">
                 <a:solidFill>
                   <a:schemeClr val="tx1"/>
                 </a:solidFill>
               </a:rPr>
-              <a:t>ALS: 12.5 s → 5.2 s on 8 cores (2.4× faster)</a:t>
+              <a:t>Overview: dataset and key results</a:t>
             </a:r>
             <a:endParaRPr lang="en-US" sz="1400" dirty="0"/>
           </a:p>
-        </p:txBody>
-      </p:sp>
-      <p:sp>
-        <p:nvSpPr>
-          <p:cNvPr id="8" name="Shape 3"/>
-          <p:cNvSpPr/>
-          <p:nvPr/>
-        </p:nvSpPr>
-        <p:spPr>
-          <a:xfrm>
-            <a:off x="4320540" y="5394960"/>
-            <a:ext cx="3520440" cy="822960"/>
-          </a:xfrm>
-          <a:prstGeom prst="roundRect">
-            <a:avLst>
-              <a:gd name="adj" fmla="val 8889"/>
-            </a:avLst>
-          </a:prstGeom>
-          <a:solidFill>
-            <a:schemeClr val="bg2"/>
-          </a:solidFill>
-          <a:ln/>
-        </p:spPr>
-      </p:sp>
-      <p:sp>
-        <p:nvSpPr>
-          <p:cNvPr id="9" name="Text 4"/>
-          <p:cNvSpPr txBox="1"/>
-          <p:nvPr/>
-        </p:nvSpPr>
-        <p:spPr>
-          <a:xfrm>
-            <a:off x="4503420" y="5394960"/>
-            <a:ext cx="3154680" cy="822960"/>
-          </a:xfrm>
-          <a:prstGeom prst="rect">
-            <a:avLst/>
-          </a:prstGeom>
-          <a:noFill/>
-          <a:ln/>
-        </p:spPr>
-        <p:txBody>
-          <a:bodyPr wrap="square" lIns="0" tIns="0" rIns="0" bIns="0" rtlCol="0" anchor="ctr"/>
-          <a:lstStyle/>
+          <a:p>
+            <a:pPr marL="342900" indent="-342900">
+              <a:spcAft>
+                <a:spcPts val="600"/>
+              </a:spcAft>
+              <a:buSzPct val="100000"/>
+              <a:buChar char="•"/>
+            </a:pPr>
+            <a:r>
+              <a:rPr lang="en-US" sz="1400" dirty="0">
+                <a:solidFill>
+                  <a:schemeClr val="tx1"/>
+                </a:solidFill>
+              </a:rPr>
+              <a:t>Recommend: any user 1–610</a:t>
+            </a:r>
+            <a:endParaRPr lang="en-US" sz="1400" dirty="0"/>
+          </a:p>
+          <a:p>
+            <a:pPr marL="342900" indent="-342900">
+              <a:spcAft>
+                <a:spcPts val="600"/>
+              </a:spcAft>
+              <a:buSzPct val="100000"/>
+              <a:buChar char="•"/>
+            </a:pPr>
+            <a:r>
+              <a:rPr lang="en-US" sz="1400" dirty="0">
+                <a:solidFill>
+                  <a:schemeClr val="tx1"/>
+                </a:solidFill>
+              </a:rPr>
+              <a:t>Graph insights</a:t>
+            </a:r>
+            <a:endParaRPr lang="en-US" sz="1400" dirty="0"/>
+          </a:p>
+          <a:p>
+            <a:pPr marL="342900" indent="-342900">
+              <a:spcAft>
+                <a:spcPts val="600"/>
+              </a:spcAft>
+              <a:buSzPct val="100000"/>
+              <a:buChar char="•"/>
+            </a:pPr>
+            <a:r>
+              <a:rPr lang="en-US" sz="1400" dirty="0">
+                <a:solidFill>
+                  <a:schemeClr val="tx1"/>
+                </a:solidFill>
+              </a:rPr>
+              <a:t>Models and scalability</a:t>
+            </a:r>
+            <a:endParaRPr lang="en-US" sz="1400" dirty="0"/>
+          </a:p>
+          <a:p>
+            <a:pPr marL="342900" indent="-342900">
+              <a:spcAft>
+                <a:spcPts val="600"/>
+              </a:spcAft>
+              <a:buSzPct val="100000"/>
+              <a:buChar char="•"/>
+            </a:pPr>
+            <a:r>
+              <a:rPr lang="en-US" sz="1400" dirty="0">
+                <a:solidFill>
+                  <a:schemeClr val="tx1"/>
+                </a:solidFill>
+              </a:rPr>
+              <a:t>Train / test split</a:t>
+            </a:r>
+            <a:endParaRPr lang="en-US" sz="1400" dirty="0"/>
+          </a:p>
           <a:p>
             <a:pPr indent="0" marL="0">
+              <a:spcAft>
+                <a:spcPts val="600"/>
+              </a:spcAft>
               <a:buNone/>
             </a:pPr>
             <a:r>
               <a:rPr lang="en-US" sz="1400" dirty="0">
                 <a:solidFill>
-                  <a:schemeClr val="tx1"/>
-                </a:solidFill>
-              </a:rPr>
-              <a:t>Fastest overall: 2 cores (15.8 s); overhead dominates on small data</a:t>
-            </a:r>
-            <a:endParaRPr lang="en-US" sz="1400" dirty="0"/>
-          </a:p>
-        </p:txBody>
-      </p:sp>
-      <p:sp>
-        <p:nvSpPr>
-          <p:cNvPr id="10" name="Shape 5"/>
-          <p:cNvSpPr/>
-          <p:nvPr/>
-        </p:nvSpPr>
-        <p:spPr>
-          <a:xfrm>
-            <a:off x="8092440" y="5394960"/>
-            <a:ext cx="3520440" cy="822960"/>
-          </a:xfrm>
-          <a:prstGeom prst="roundRect">
-            <a:avLst>
-              <a:gd name="adj" fmla="val 8889"/>
-            </a:avLst>
-          </a:prstGeom>
-          <a:solidFill>
-            <a:schemeClr val="bg2"/>
-          </a:solidFill>
-          <a:ln/>
-        </p:spPr>
-      </p:sp>
-      <p:sp>
-        <p:nvSpPr>
-          <p:cNvPr id="11" name="Text 6"/>
-          <p:cNvSpPr txBox="1"/>
-          <p:nvPr/>
-        </p:nvSpPr>
-        <p:spPr>
-          <a:xfrm>
-            <a:off x="8275320" y="5394960"/>
-            <a:ext cx="3154680" cy="822960"/>
-          </a:xfrm>
-          <a:prstGeom prst="rect">
-            <a:avLst/>
-          </a:prstGeom>
-          <a:noFill/>
-          <a:ln/>
-        </p:spPr>
-        <p:txBody>
-          <a:bodyPr wrap="square" lIns="0" tIns="0" rIns="0" bIns="0" rtlCol="0" anchor="ctr"/>
-          <a:lstStyle/>
-          <a:p>
-            <a:pPr indent="0" marL="0">
-              <a:buNone/>
-            </a:pPr>
-            <a:r>
-              <a:rPr lang="en-US" sz="1400" dirty="0">
-                <a:solidFill>
-                  <a:schemeClr val="tx1"/>
-                </a:solidFill>
-              </a:rPr>
-              <a:t>More data → lower error: RMSE 1.012 → 0.881</a:t>
+                  <a:srgbClr val="555B6E"/>
+                </a:solidFill>
+              </a:rPr>
+              <a:t>Streamlit on Render; reads saved results, so no Spark is needed on the server</a:t>
             </a:r>
             <a:endParaRPr lang="en-US" sz="1400" dirty="0"/>
           </a:p>
@@ -12910,42 +13153,146 @@
                   <a:schemeClr val="tx1"/>
                 </a:solidFill>
               </a:rPr>
-              <a:t>Execution time per stage</a:t>
+              <a:t>Dashboard: recommendations and graph insights</a:t>
             </a:r>
             <a:endParaRPr lang="en-US" sz="3600" dirty="0"/>
           </a:p>
         </p:txBody>
       </p:sp>
-      <p:graphicFrame>
-        <p:nvGraphicFramePr>
-          <p:cNvPr id="4" name="Chart 0" descr=""/>
-          <p:cNvGraphicFramePr/>
-          <p:nvPr/>
-        </p:nvGraphicFramePr>
-        <p:xfrm>
-          <a:off x="548640" y="1325880"/>
-          <a:ext cx="7315200" cy="4892040"/>
-        </p:xfrm>
-        <a:graphic xmlns:a="http://schemas.openxmlformats.org/drawingml/2006/main">
-          <a:graphicData uri="http://schemas.openxmlformats.org/drawingml/2006/chart">
-            <c:chart xmlns:c="http://schemas.openxmlformats.org/drawingml/2006/chart" r:id="rId1"/>
-          </a:graphicData>
-        </a:graphic>
-      </p:graphicFrame>
-      <p:sp>
-        <p:nvSpPr>
-          <p:cNvPr id="5" name="Shape 1"/>
+      <p:pic>
+        <p:nvPicPr>
+          <p:cNvPr id="4" name="Image 0" descr="Recommend tab: user 1's favourites and top-10 picks">    </p:cNvPr>
+          <p:cNvPicPr>
+            <a:picLocks noChangeAspect="1"/>
+          </p:cNvPicPr>
+          <p:nvPr/>
+        </p:nvPicPr>
+        <p:blipFill>
+          <a:blip r:embed="rId1"/>
+          <a:stretch>
+            <a:fillRect/>
+          </a:stretch>
+        </p:blipFill>
+        <p:spPr>
+          <a:xfrm>
+            <a:off x="548640" y="1463040"/>
+            <a:ext cx="5440680" cy="3400425"/>
+          </a:xfrm>
+          <a:prstGeom prst="rect">
+            <a:avLst/>
+          </a:prstGeom>
+        </p:spPr>
+      </p:pic>
+      <p:sp>
+        <p:nvSpPr>
+          <p:cNvPr id="5" name="Text 1"/>
+          <p:cNvSpPr txBox="1"/>
+          <p:nvPr/>
+        </p:nvSpPr>
+        <p:spPr>
+          <a:xfrm>
+            <a:off x="548640" y="4973193"/>
+            <a:ext cx="5440680" cy="320040"/>
+          </a:xfrm>
+          <a:prstGeom prst="rect">
+            <a:avLst/>
+          </a:prstGeom>
+          <a:noFill/>
+          <a:ln/>
+        </p:spPr>
+        <p:txBody>
+          <a:bodyPr wrap="square" lIns="0" tIns="0" rIns="0" bIns="0" rtlCol="0" anchor="t"/>
+          <a:lstStyle/>
+          <a:p>
+            <a:pPr indent="0" marL="0">
+              <a:buNone/>
+            </a:pPr>
+            <a:r>
+              <a:rPr lang="en-US" sz="1200" i="1" dirty="0">
+                <a:solidFill>
+                  <a:srgbClr val="555B6E"/>
+                </a:solidFill>
+              </a:rPr>
+              <a:t>Recommend tab: user 1's favourites and top-10 picks</a:t>
+            </a:r>
+            <a:endParaRPr lang="en-US" sz="1200" dirty="0"/>
+          </a:p>
+        </p:txBody>
+      </p:sp>
+      <p:pic>
+        <p:nvPicPr>
+          <p:cNvPr id="6" name="Image 1" descr="Graph insights tab: PageRank and communities">    </p:cNvPr>
+          <p:cNvPicPr>
+            <a:picLocks noChangeAspect="1"/>
+          </p:cNvPicPr>
+          <p:nvPr/>
+        </p:nvPicPr>
+        <p:blipFill>
+          <a:blip r:embed="rId2"/>
+          <a:stretch>
+            <a:fillRect/>
+          </a:stretch>
+        </p:blipFill>
+        <p:spPr>
+          <a:xfrm>
+            <a:off x="6172200" y="1463040"/>
+            <a:ext cx="5440680" cy="3400425"/>
+          </a:xfrm>
+          <a:prstGeom prst="rect">
+            <a:avLst/>
+          </a:prstGeom>
+        </p:spPr>
+      </p:pic>
+      <p:sp>
+        <p:nvSpPr>
+          <p:cNvPr id="7" name="Text 2"/>
+          <p:cNvSpPr txBox="1"/>
+          <p:nvPr/>
+        </p:nvSpPr>
+        <p:spPr>
+          <a:xfrm>
+            <a:off x="6172200" y="4973193"/>
+            <a:ext cx="5440680" cy="320040"/>
+          </a:xfrm>
+          <a:prstGeom prst="rect">
+            <a:avLst/>
+          </a:prstGeom>
+          <a:noFill/>
+          <a:ln/>
+        </p:spPr>
+        <p:txBody>
+          <a:bodyPr wrap="square" lIns="0" tIns="0" rIns="0" bIns="0" rtlCol="0" anchor="t"/>
+          <a:lstStyle/>
+          <a:p>
+            <a:pPr indent="0" marL="0">
+              <a:buNone/>
+            </a:pPr>
+            <a:r>
+              <a:rPr lang="en-US" sz="1200" i="1" dirty="0">
+                <a:solidFill>
+                  <a:srgbClr val="555B6E"/>
+                </a:solidFill>
+              </a:rPr>
+              <a:t>Graph insights tab: PageRank and communities</a:t>
+            </a:r>
+            <a:endParaRPr lang="en-US" sz="1200" dirty="0"/>
+          </a:p>
+        </p:txBody>
+      </p:sp>
+      <p:sp>
+        <p:nvSpPr>
+          <p:cNvPr id="8" name="Shape 3"/>
           <p:cNvSpPr/>
           <p:nvPr/>
         </p:nvSpPr>
         <p:spPr>
           <a:xfrm>
-            <a:off x="8138160" y="1325880"/>
-            <a:ext cx="3474720" cy="1508760"/>
+            <a:off x="548640" y="5486400"/>
+            <a:ext cx="11064240" cy="731520"/>
           </a:xfrm>
           <a:prstGeom prst="roundRect">
             <a:avLst>
-              <a:gd name="adj" fmla="val 4848"/>
+              <a:gd name="adj" fmla="val 10000"/>
             </a:avLst>
           </a:prstGeom>
           <a:solidFill>
@@ -12956,14 +13303,14 @@
       </p:sp>
       <p:sp>
         <p:nvSpPr>
-          <p:cNvPr id="6" name="Text 2"/>
+          <p:cNvPr id="9" name="Text 4"/>
           <p:cNvSpPr txBox="1"/>
           <p:nvPr/>
         </p:nvSpPr>
         <p:spPr>
           <a:xfrm>
-            <a:off x="8366760" y="1508760"/>
-            <a:ext cx="3017520" cy="685800"/>
+            <a:off x="777240" y="5486400"/>
+            <a:ext cx="10607040" cy="731520"/>
           </a:xfrm>
           <a:prstGeom prst="rect">
             <a:avLst/>
@@ -12979,238 +13326,14 @@
               <a:buNone/>
             </a:pPr>
             <a:r>
-              <a:rPr lang="en-US" sz="3600" b="1" dirty="0">
-                <a:solidFill>
-                  <a:schemeClr val="accent2"/>
-                </a:solidFill>
-              </a:rPr>
-              <a:t>7.8 min</a:t>
-            </a:r>
-            <a:endParaRPr lang="en-US" sz="3600" dirty="0"/>
-          </a:p>
-        </p:txBody>
-      </p:sp>
-      <p:sp>
-        <p:nvSpPr>
-          <p:cNvPr id="7" name="Text 3"/>
-          <p:cNvSpPr txBox="1"/>
-          <p:nvPr/>
-        </p:nvSpPr>
-        <p:spPr>
-          <a:xfrm>
-            <a:off x="8366760" y="2221992"/>
-            <a:ext cx="3017520" cy="457200"/>
-          </a:xfrm>
-          <a:prstGeom prst="rect">
-            <a:avLst/>
-          </a:prstGeom>
-          <a:noFill/>
-          <a:ln/>
-        </p:spPr>
-        <p:txBody>
-          <a:bodyPr wrap="square" lIns="0" tIns="0" rIns="0" bIns="0" rtlCol="0" anchor="t"/>
-          <a:lstStyle/>
-          <a:p>
-            <a:pPr indent="0" marL="0">
-              <a:buNone/>
-            </a:pPr>
-            <a:r>
-              <a:rPr lang="en-US" sz="1400" dirty="0">
+              <a:rPr lang="en-US" sz="1500" dirty="0">
                 <a:solidFill>
                   <a:schemeClr val="tx1"/>
                 </a:solidFill>
               </a:rPr>
-              <a:t>for the whole pipeline, all 11 stages</a:t>
-            </a:r>
-            <a:endParaRPr lang="en-US" sz="1400" dirty="0"/>
-          </a:p>
-        </p:txBody>
-      </p:sp>
-      <p:sp>
-        <p:nvSpPr>
-          <p:cNvPr id="8" name="Shape 4"/>
-          <p:cNvSpPr/>
-          <p:nvPr/>
-        </p:nvSpPr>
-        <p:spPr>
-          <a:xfrm>
-            <a:off x="8138160" y="3017520"/>
-            <a:ext cx="3474720" cy="1508760"/>
-          </a:xfrm>
-          <a:prstGeom prst="roundRect">
-            <a:avLst>
-              <a:gd name="adj" fmla="val 4848"/>
-            </a:avLst>
-          </a:prstGeom>
-          <a:solidFill>
-            <a:schemeClr val="bg2"/>
-          </a:solidFill>
-          <a:ln/>
-        </p:spPr>
-      </p:sp>
-      <p:sp>
-        <p:nvSpPr>
-          <p:cNvPr id="9" name="Text 5"/>
-          <p:cNvSpPr txBox="1"/>
-          <p:nvPr/>
-        </p:nvSpPr>
-        <p:spPr>
-          <a:xfrm>
-            <a:off x="8366760" y="3200400"/>
-            <a:ext cx="3017520" cy="685800"/>
-          </a:xfrm>
-          <a:prstGeom prst="rect">
-            <a:avLst/>
-          </a:prstGeom>
-          <a:noFill/>
-          <a:ln/>
-        </p:spPr>
-        <p:txBody>
-          <a:bodyPr wrap="square" lIns="0" tIns="0" rIns="0" bIns="0" rtlCol="0" anchor="ctr"/>
-          <a:lstStyle/>
-          <a:p>
-            <a:pPr indent="0" marL="0">
-              <a:buNone/>
-            </a:pPr>
-            <a:r>
-              <a:rPr lang="en-US" sz="3600" b="1" dirty="0">
-                <a:solidFill>
-                  <a:schemeClr val="accent2"/>
-                </a:solidFill>
-              </a:rPr>
-              <a:t>173 s</a:t>
-            </a:r>
-            <a:endParaRPr lang="en-US" sz="3600" dirty="0"/>
-          </a:p>
-        </p:txBody>
-      </p:sp>
-      <p:sp>
-        <p:nvSpPr>
-          <p:cNvPr id="10" name="Text 6"/>
-          <p:cNvSpPr txBox="1"/>
-          <p:nvPr/>
-        </p:nvSpPr>
-        <p:spPr>
-          <a:xfrm>
-            <a:off x="8366760" y="3913632"/>
-            <a:ext cx="3017520" cy="457200"/>
-          </a:xfrm>
-          <a:prstGeom prst="rect">
-            <a:avLst/>
-          </a:prstGeom>
-          <a:noFill/>
-          <a:ln/>
-        </p:spPr>
-        <p:txBody>
-          <a:bodyPr wrap="square" lIns="0" tIns="0" rIns="0" bIns="0" rtlCol="0" anchor="t"/>
-          <a:lstStyle/>
-          <a:p>
-            <a:pPr indent="0" marL="0">
-              <a:buNone/>
-            </a:pPr>
-            <a:r>
-              <a:rPr lang="en-US" sz="1400" dirty="0">
-                <a:solidFill>
-                  <a:schemeClr val="tx1"/>
-                </a:solidFill>
-              </a:rPr>
-              <a:t>Model B tuning: the slowest stage (8 models)</a:t>
-            </a:r>
-            <a:endParaRPr lang="en-US" sz="1400" dirty="0"/>
-          </a:p>
-        </p:txBody>
-      </p:sp>
-      <p:sp>
-        <p:nvSpPr>
-          <p:cNvPr id="11" name="Shape 7"/>
-          <p:cNvSpPr/>
-          <p:nvPr/>
-        </p:nvSpPr>
-        <p:spPr>
-          <a:xfrm>
-            <a:off x="8138160" y="4709160"/>
-            <a:ext cx="3474720" cy="1508760"/>
-          </a:xfrm>
-          <a:prstGeom prst="roundRect">
-            <a:avLst>
-              <a:gd name="adj" fmla="val 4848"/>
-            </a:avLst>
-          </a:prstGeom>
-          <a:solidFill>
-            <a:schemeClr val="bg2"/>
-          </a:solidFill>
-          <a:ln/>
-        </p:spPr>
-      </p:sp>
-      <p:sp>
-        <p:nvSpPr>
-          <p:cNvPr id="12" name="Text 8"/>
-          <p:cNvSpPr txBox="1"/>
-          <p:nvPr/>
-        </p:nvSpPr>
-        <p:spPr>
-          <a:xfrm>
-            <a:off x="8366760" y="4892040"/>
-            <a:ext cx="3017520" cy="685800"/>
-          </a:xfrm>
-          <a:prstGeom prst="rect">
-            <a:avLst/>
-          </a:prstGeom>
-          <a:noFill/>
-          <a:ln/>
-        </p:spPr>
-        <p:txBody>
-          <a:bodyPr wrap="square" lIns="0" tIns="0" rIns="0" bIns="0" rtlCol="0" anchor="ctr"/>
-          <a:lstStyle/>
-          <a:p>
-            <a:pPr indent="0" marL="0">
-              <a:buNone/>
-            </a:pPr>
-            <a:r>
-              <a:rPr lang="en-US" sz="3600" b="1" dirty="0">
-                <a:solidFill>
-                  <a:schemeClr val="accent4"/>
-                </a:solidFill>
-              </a:rPr>
-              <a:t>4.6 s</a:t>
-            </a:r>
-            <a:endParaRPr lang="en-US" sz="3600" dirty="0"/>
-          </a:p>
-        </p:txBody>
-      </p:sp>
-      <p:sp>
-        <p:nvSpPr>
-          <p:cNvPr id="13" name="Text 9"/>
-          <p:cNvSpPr txBox="1"/>
-          <p:nvPr/>
-        </p:nvSpPr>
-        <p:spPr>
-          <a:xfrm>
-            <a:off x="8366760" y="5605272"/>
-            <a:ext cx="3017520" cy="457200"/>
-          </a:xfrm>
-          <a:prstGeom prst="rect">
-            <a:avLst/>
-          </a:prstGeom>
-          <a:noFill/>
-          <a:ln/>
-        </p:spPr>
-        <p:txBody>
-          <a:bodyPr wrap="square" lIns="0" tIns="0" rIns="0" bIns="0" rtlCol="0" anchor="t"/>
-          <a:lstStyle/>
-          <a:p>
-            <a:pPr indent="0" marL="0">
-              <a:buNone/>
-            </a:pPr>
-            <a:r>
-              <a:rPr lang="en-US" sz="1400" dirty="0">
-                <a:solidFill>
-                  <a:schemeClr val="tx1"/>
-                </a:solidFill>
-              </a:rPr>
-              <a:t>to train one ALS model on 80,886 ratings</a:t>
-            </a:r>
-            <a:endParaRPr lang="en-US" sz="1400" dirty="0"/>
+              <a:t>Live at movie-recommendation-spark.onrender.com  ·  source on GitHub: github.com/Nitesh1123/movie-recommendation-spark</a:t>
+            </a:r>
+            <a:endParaRPr lang="en-US" sz="1500" dirty="0"/>
           </a:p>
         </p:txBody>
       </p:sp>
@@ -13316,170 +13439,58 @@
                   <a:schemeClr val="tx1"/>
                 </a:solidFill>
               </a:rPr>
-              <a:t>Verification: 29 automated checks</a:t>
+              <a:t>Scalability experiments</a:t>
             </a:r>
             <a:endParaRPr lang="en-US" sz="3600" dirty="0"/>
           </a:p>
         </p:txBody>
       </p:sp>
-      <p:sp>
-        <p:nvSpPr>
-          <p:cNvPr id="4" name="Shape 1"/>
+      <p:graphicFrame>
+        <p:nvGraphicFramePr>
+          <p:cNvPr id="4" name="Chart 0" descr=""/>
+          <p:cNvGraphicFramePr/>
+          <p:nvPr/>
+        </p:nvGraphicFramePr>
+        <p:xfrm>
+          <a:off x="548640" y="1325880"/>
+          <a:ext cx="5486400" cy="3886200"/>
+        </p:xfrm>
+        <a:graphic xmlns:a="http://schemas.openxmlformats.org/drawingml/2006/main">
+          <a:graphicData uri="http://schemas.openxmlformats.org/drawingml/2006/chart">
+            <c:chart xmlns:c="http://schemas.openxmlformats.org/drawingml/2006/chart" r:id="rId1"/>
+          </a:graphicData>
+        </a:graphic>
+      </p:graphicFrame>
+      <p:graphicFrame>
+        <p:nvGraphicFramePr>
+          <p:cNvPr id="5" name="Chart 1" descr=""/>
+          <p:cNvGraphicFramePr/>
+          <p:nvPr/>
+        </p:nvGraphicFramePr>
+        <p:xfrm>
+          <a:off x="6126480" y="1325880"/>
+          <a:ext cx="5486400" cy="3886200"/>
+        </p:xfrm>
+        <a:graphic xmlns:a="http://schemas.openxmlformats.org/drawingml/2006/main">
+          <a:graphicData uri="http://schemas.openxmlformats.org/drawingml/2006/chart">
+            <c:chart xmlns:c="http://schemas.openxmlformats.org/drawingml/2006/chart" r:id="rId2"/>
+          </a:graphicData>
+        </a:graphic>
+      </p:graphicFrame>
+      <p:sp>
+        <p:nvSpPr>
+          <p:cNvPr id="6" name="Shape 1"/>
           <p:cNvSpPr/>
           <p:nvPr/>
         </p:nvSpPr>
         <p:spPr>
           <a:xfrm>
-            <a:off x="548640" y="1371600"/>
-            <a:ext cx="3291840" cy="4846320"/>
+            <a:off x="548640" y="5394960"/>
+            <a:ext cx="3520440" cy="822960"/>
           </a:xfrm>
           <a:prstGeom prst="roundRect">
             <a:avLst>
-              <a:gd name="adj" fmla="val 2222"/>
-            </a:avLst>
-          </a:prstGeom>
-          <a:solidFill>
-            <a:schemeClr val="tx2"/>
-          </a:solidFill>
-          <a:ln/>
-        </p:spPr>
-      </p:sp>
-      <p:sp>
-        <p:nvSpPr>
-          <p:cNvPr id="5" name="Text 2"/>
-          <p:cNvSpPr txBox="1"/>
-          <p:nvPr/>
-        </p:nvSpPr>
-        <p:spPr>
-          <a:xfrm>
-            <a:off x="777240" y="2011680"/>
-            <a:ext cx="2834640" cy="1005840"/>
-          </a:xfrm>
-          <a:prstGeom prst="rect">
-            <a:avLst/>
-          </a:prstGeom>
-          <a:noFill/>
-          <a:ln/>
-        </p:spPr>
-        <p:txBody>
-          <a:bodyPr wrap="square" lIns="0" tIns="0" rIns="0" bIns="0" rtlCol="0" anchor="t"/>
-          <a:lstStyle/>
-          <a:p>
-            <a:pPr algn="ctr" indent="0" marL="0">
-              <a:buNone/>
-            </a:pPr>
-            <a:r>
-              <a:rPr lang="en-US" sz="5400" b="1" dirty="0">
-                <a:solidFill>
-                  <a:schemeClr val="accent1"/>
-                </a:solidFill>
-              </a:rPr>
-              <a:t>29/29</a:t>
-            </a:r>
-            <a:endParaRPr lang="en-US" sz="5400" dirty="0"/>
-          </a:p>
-        </p:txBody>
-      </p:sp>
-      <p:sp>
-        <p:nvSpPr>
-          <p:cNvPr id="6" name="Text 3"/>
-          <p:cNvSpPr txBox="1"/>
-          <p:nvPr/>
-        </p:nvSpPr>
-        <p:spPr>
-          <a:xfrm>
-            <a:off x="777240" y="3063240"/>
-            <a:ext cx="2834640" cy="822960"/>
-          </a:xfrm>
-          <a:prstGeom prst="rect">
-            <a:avLst/>
-          </a:prstGeom>
-          <a:noFill/>
-          <a:ln/>
-        </p:spPr>
-        <p:txBody>
-          <a:bodyPr wrap="square" lIns="0" tIns="0" rIns="0" bIns="0" rtlCol="0" anchor="t"/>
-          <a:lstStyle/>
-          <a:p>
-            <a:pPr algn="ctr" indent="0" marL="0">
-              <a:buNone/>
-            </a:pPr>
-            <a:r>
-              <a:rPr lang="en-US" sz="1600" dirty="0">
-                <a:solidFill>
-                  <a:schemeClr val="bg1"/>
-                </a:solidFill>
-              </a:rPr>
-              <a:t>checks passed</a:t>
-            </a:r>
-            <a:endParaRPr lang="en-US" sz="1600" dirty="0"/>
-          </a:p>
-          <a:p>
-            <a:pPr algn="ctr" indent="0" marL="0">
-              <a:buNone/>
-            </a:pPr>
-            <a:r>
-              <a:rPr lang="en-US" sz="1600" dirty="0">
-                <a:solidFill>
-                  <a:schemeClr val="bg1"/>
-                </a:solidFill>
-              </a:rPr>
-              <a:t>(python verify.py)</a:t>
-            </a:r>
-            <a:endParaRPr lang="en-US" sz="1600" dirty="0"/>
-          </a:p>
-        </p:txBody>
-      </p:sp>
-      <p:sp>
-        <p:nvSpPr>
-          <p:cNvPr id="7" name="Text 4"/>
-          <p:cNvSpPr txBox="1"/>
-          <p:nvPr/>
-        </p:nvSpPr>
-        <p:spPr>
-          <a:xfrm>
-            <a:off x="777240" y="4343400"/>
-            <a:ext cx="2834640" cy="1188720"/>
-          </a:xfrm>
-          <a:prstGeom prst="rect">
-            <a:avLst/>
-          </a:prstGeom>
-          <a:noFill/>
-          <a:ln/>
-        </p:spPr>
-        <p:txBody>
-          <a:bodyPr wrap="square" lIns="0" tIns="0" rIns="0" bIns="0" rtlCol="0" anchor="t"/>
-          <a:lstStyle/>
-          <a:p>
-            <a:pPr algn="ctr" indent="0" marL="0">
-              <a:buNone/>
-            </a:pPr>
-            <a:r>
-              <a:rPr lang="en-US" sz="1400" dirty="0">
-                <a:solidFill>
-                  <a:schemeClr val="accent5"/>
-                </a:solidFill>
-              </a:rPr>
-              <a:t>Spark results recounted with plain pandas, without Spark</a:t>
-            </a:r>
-            <a:endParaRPr lang="en-US" sz="1400" dirty="0"/>
-          </a:p>
-        </p:txBody>
-      </p:sp>
-      <p:sp>
-        <p:nvSpPr>
-          <p:cNvPr id="8" name="Shape 5"/>
-          <p:cNvSpPr/>
-          <p:nvPr/>
-        </p:nvSpPr>
-        <p:spPr>
-          <a:xfrm>
-            <a:off x="4114800" y="1371600"/>
-            <a:ext cx="2331720" cy="2331720"/>
-          </a:xfrm>
-          <a:prstGeom prst="roundRect">
-            <a:avLst>
-              <a:gd name="adj" fmla="val 3137"/>
+              <a:gd name="adj" fmla="val 8889"/>
             </a:avLst>
           </a:prstGeom>
           <a:solidFill>
@@ -13490,14 +13501,14 @@
       </p:sp>
       <p:sp>
         <p:nvSpPr>
-          <p:cNvPr id="9" name="Text 6"/>
+          <p:cNvPr id="7" name="Text 2"/>
           <p:cNvSpPr txBox="1"/>
           <p:nvPr/>
         </p:nvSpPr>
         <p:spPr>
           <a:xfrm>
-            <a:off x="4297680" y="1508760"/>
-            <a:ext cx="1965960" cy="685800"/>
+            <a:off x="731520" y="5394960"/>
+            <a:ext cx="3154680" cy="822960"/>
           </a:xfrm>
           <a:prstGeom prst="rect">
             <a:avLst/>
@@ -13506,110 +13517,38 @@
           <a:ln/>
         </p:spPr>
         <p:txBody>
-          <a:bodyPr wrap="square" lIns="0" tIns="0" rIns="0" bIns="0" rtlCol="0" anchor="t"/>
+          <a:bodyPr wrap="square" lIns="0" tIns="0" rIns="0" bIns="0" rtlCol="0" anchor="ctr"/>
           <a:lstStyle/>
           <a:p>
             <a:pPr indent="0" marL="0">
               <a:buNone/>
             </a:pPr>
             <a:r>
-              <a:rPr lang="en-US" sz="3600" b="1" dirty="0">
-                <a:solidFill>
-                  <a:schemeClr val="accent4"/>
-                </a:solidFill>
-              </a:rPr>
-              <a:t>3</a:t>
-            </a:r>
-            <a:endParaRPr lang="en-US" sz="3600" dirty="0"/>
-          </a:p>
-        </p:txBody>
-      </p:sp>
-      <p:sp>
-        <p:nvSpPr>
-          <p:cNvPr id="10" name="Text 7"/>
-          <p:cNvSpPr txBox="1"/>
-          <p:nvPr/>
-        </p:nvSpPr>
-        <p:spPr>
-          <a:xfrm>
-            <a:off x="4297680" y="2194560"/>
-            <a:ext cx="1965960" cy="411480"/>
-          </a:xfrm>
-          <a:prstGeom prst="rect">
-            <a:avLst/>
-          </a:prstGeom>
-          <a:noFill/>
-          <a:ln/>
-        </p:spPr>
-        <p:txBody>
-          <a:bodyPr wrap="square" lIns="0" tIns="0" rIns="0" bIns="0" rtlCol="0" anchor="t"/>
-          <a:lstStyle/>
-          <a:p>
-            <a:pPr indent="0" marL="0">
-              <a:buNone/>
-            </a:pPr>
-            <a:r>
-              <a:rPr lang="en-US" sz="1600" b="1" dirty="0">
+              <a:rPr lang="en-US" sz="1400" dirty="0">
                 <a:solidFill>
                   <a:schemeClr val="tx1"/>
                 </a:solidFill>
               </a:rPr>
-              <a:t>Outputs exist</a:t>
-            </a:r>
-            <a:endParaRPr lang="en-US" sz="1600" dirty="0"/>
-          </a:p>
-        </p:txBody>
-      </p:sp>
-      <p:sp>
-        <p:nvSpPr>
-          <p:cNvPr id="11" name="Text 8"/>
-          <p:cNvSpPr txBox="1"/>
-          <p:nvPr/>
-        </p:nvSpPr>
-        <p:spPr>
-          <a:xfrm>
-            <a:off x="4297680" y="2606040"/>
-            <a:ext cx="1965960" cy="1005840"/>
-          </a:xfrm>
-          <a:prstGeom prst="rect">
-            <a:avLst/>
-          </a:prstGeom>
-          <a:noFill/>
-          <a:ln/>
-        </p:spPr>
-        <p:txBody>
-          <a:bodyPr wrap="square" lIns="0" tIns="0" rIns="0" bIns="0" rtlCol="0" anchor="t"/>
-          <a:lstStyle/>
-          <a:p>
-            <a:pPr indent="0" marL="0">
-              <a:buNone/>
-            </a:pPr>
-            <a:r>
-              <a:rPr lang="en-US" sz="1300" dirty="0">
-                <a:solidFill>
-                  <a:schemeClr val="tx1"/>
-                </a:solidFill>
-              </a:rPr>
-              <a:t>metrics, charts and result tables</a:t>
-            </a:r>
-            <a:endParaRPr lang="en-US" sz="1300" dirty="0"/>
-          </a:p>
-        </p:txBody>
-      </p:sp>
-      <p:sp>
-        <p:nvSpPr>
-          <p:cNvPr id="12" name="Shape 9"/>
+              <a:t>ALS: 12.5 s → 5.2 s on 8 cores (2.4× faster)</a:t>
+            </a:r>
+            <a:endParaRPr lang="en-US" sz="1400" dirty="0"/>
+          </a:p>
+        </p:txBody>
+      </p:sp>
+      <p:sp>
+        <p:nvSpPr>
+          <p:cNvPr id="8" name="Shape 3"/>
           <p:cNvSpPr/>
           <p:nvPr/>
         </p:nvSpPr>
         <p:spPr>
           <a:xfrm>
-            <a:off x="6697980" y="1371600"/>
-            <a:ext cx="2331720" cy="2331720"/>
+            <a:off x="4320540" y="5394960"/>
+            <a:ext cx="3520440" cy="822960"/>
           </a:xfrm>
           <a:prstGeom prst="roundRect">
             <a:avLst>
-              <a:gd name="adj" fmla="val 3137"/>
+              <a:gd name="adj" fmla="val 8889"/>
             </a:avLst>
           </a:prstGeom>
           <a:solidFill>
@@ -13620,14 +13559,14 @@
       </p:sp>
       <p:sp>
         <p:nvSpPr>
-          <p:cNvPr id="13" name="Text 10"/>
+          <p:cNvPr id="9" name="Text 4"/>
           <p:cNvSpPr txBox="1"/>
           <p:nvPr/>
         </p:nvSpPr>
         <p:spPr>
           <a:xfrm>
-            <a:off x="6880860" y="1508760"/>
-            <a:ext cx="1965960" cy="685800"/>
+            <a:off x="4503420" y="5394960"/>
+            <a:ext cx="3154680" cy="822960"/>
           </a:xfrm>
           <a:prstGeom prst="rect">
             <a:avLst/>
@@ -13636,110 +13575,38 @@
           <a:ln/>
         </p:spPr>
         <p:txBody>
-          <a:bodyPr wrap="square" lIns="0" tIns="0" rIns="0" bIns="0" rtlCol="0" anchor="t"/>
+          <a:bodyPr wrap="square" lIns="0" tIns="0" rIns="0" bIns="0" rtlCol="0" anchor="ctr"/>
           <a:lstStyle/>
           <a:p>
             <a:pPr indent="0" marL="0">
               <a:buNone/>
             </a:pPr>
             <a:r>
-              <a:rPr lang="en-US" sz="3600" b="1" dirty="0">
-                <a:solidFill>
-                  <a:schemeClr val="accent4"/>
-                </a:solidFill>
-              </a:rPr>
-              <a:t>8</a:t>
-            </a:r>
-            <a:endParaRPr lang="en-US" sz="3600" dirty="0"/>
-          </a:p>
-        </p:txBody>
-      </p:sp>
-      <p:sp>
-        <p:nvSpPr>
-          <p:cNvPr id="14" name="Text 11"/>
-          <p:cNvSpPr txBox="1"/>
-          <p:nvPr/>
-        </p:nvSpPr>
-        <p:spPr>
-          <a:xfrm>
-            <a:off x="6880860" y="2194560"/>
-            <a:ext cx="1965960" cy="411480"/>
-          </a:xfrm>
-          <a:prstGeom prst="rect">
-            <a:avLst/>
-          </a:prstGeom>
-          <a:noFill/>
-          <a:ln/>
-        </p:spPr>
-        <p:txBody>
-          <a:bodyPr wrap="square" lIns="0" tIns="0" rIns="0" bIns="0" rtlCol="0" anchor="t"/>
-          <a:lstStyle/>
-          <a:p>
-            <a:pPr indent="0" marL="0">
-              <a:buNone/>
-            </a:pPr>
-            <a:r>
-              <a:rPr lang="en-US" sz="1600" b="1" dirty="0">
+              <a:rPr lang="en-US" sz="1400" dirty="0">
                 <a:solidFill>
                   <a:schemeClr val="tx1"/>
                 </a:solidFill>
               </a:rPr>
-              <a:t>Matches pandas</a:t>
-            </a:r>
-            <a:endParaRPr lang="en-US" sz="1600" dirty="0"/>
-          </a:p>
-        </p:txBody>
-      </p:sp>
-      <p:sp>
-        <p:nvSpPr>
-          <p:cNvPr id="15" name="Text 12"/>
-          <p:cNvSpPr txBox="1"/>
-          <p:nvPr/>
-        </p:nvSpPr>
-        <p:spPr>
-          <a:xfrm>
-            <a:off x="6880860" y="2606040"/>
-            <a:ext cx="1965960" cy="1005840"/>
-          </a:xfrm>
-          <a:prstGeom prst="rect">
-            <a:avLst/>
-          </a:prstGeom>
-          <a:noFill/>
-          <a:ln/>
-        </p:spPr>
-        <p:txBody>
-          <a:bodyPr wrap="square" lIns="0" tIns="0" rIns="0" bIns="0" rtlCol="0" anchor="t"/>
-          <a:lstStyle/>
-          <a:p>
-            <a:pPr indent="0" marL="0">
-              <a:buNone/>
-            </a:pPr>
-            <a:r>
-              <a:rPr lang="en-US" sz="1300" dirty="0">
-                <a:solidFill>
-                  <a:schemeClr val="tx1"/>
-                </a:solidFill>
-              </a:rPr>
-              <a:t>counts, average rating, top-3 movies, graph size</a:t>
-            </a:r>
-            <a:endParaRPr lang="en-US" sz="1300" dirty="0"/>
-          </a:p>
-        </p:txBody>
-      </p:sp>
-      <p:sp>
-        <p:nvSpPr>
-          <p:cNvPr id="16" name="Shape 13"/>
+              <a:t>Fastest overall: 2 cores (15.8 s); overhead dominates on small data</a:t>
+            </a:r>
+            <a:endParaRPr lang="en-US" sz="1400" dirty="0"/>
+          </a:p>
+        </p:txBody>
+      </p:sp>
+      <p:sp>
+        <p:nvSpPr>
+          <p:cNvPr id="10" name="Shape 5"/>
           <p:cNvSpPr/>
           <p:nvPr/>
         </p:nvSpPr>
         <p:spPr>
           <a:xfrm>
-            <a:off x="9281160" y="1371600"/>
-            <a:ext cx="2331720" cy="2331720"/>
+            <a:off x="8092440" y="5394960"/>
+            <a:ext cx="3520440" cy="822960"/>
           </a:xfrm>
           <a:prstGeom prst="roundRect">
             <a:avLst>
-              <a:gd name="adj" fmla="val 3137"/>
+              <a:gd name="adj" fmla="val 8889"/>
             </a:avLst>
           </a:prstGeom>
           <a:solidFill>
@@ -13750,14 +13617,14 @@
       </p:sp>
       <p:sp>
         <p:nvSpPr>
-          <p:cNvPr id="17" name="Text 14"/>
+          <p:cNvPr id="11" name="Text 6"/>
           <p:cNvSpPr txBox="1"/>
           <p:nvPr/>
         </p:nvSpPr>
         <p:spPr>
           <a:xfrm>
-            <a:off x="9464040" y="1508760"/>
-            <a:ext cx="1965960" cy="685800"/>
+            <a:off x="8275320" y="5394960"/>
+            <a:ext cx="3154680" cy="822960"/>
           </a:xfrm>
           <a:prstGeom prst="rect">
             <a:avLst/>
@@ -13766,483 +13633,21 @@
           <a:ln/>
         </p:spPr>
         <p:txBody>
-          <a:bodyPr wrap="square" lIns="0" tIns="0" rIns="0" bIns="0" rtlCol="0" anchor="t"/>
+          <a:bodyPr wrap="square" lIns="0" tIns="0" rIns="0" bIns="0" rtlCol="0" anchor="ctr"/>
           <a:lstStyle/>
           <a:p>
             <a:pPr indent="0" marL="0">
               <a:buNone/>
             </a:pPr>
             <a:r>
-              <a:rPr lang="en-US" sz="3600" b="1" dirty="0">
-                <a:solidFill>
-                  <a:schemeClr val="accent4"/>
-                </a:solidFill>
-              </a:rPr>
-              <a:t>5</a:t>
-            </a:r>
-            <a:endParaRPr lang="en-US" sz="3600" dirty="0"/>
-          </a:p>
-        </p:txBody>
-      </p:sp>
-      <p:sp>
-        <p:nvSpPr>
-          <p:cNvPr id="18" name="Text 15"/>
-          <p:cNvSpPr txBox="1"/>
-          <p:nvPr/>
-        </p:nvSpPr>
-        <p:spPr>
-          <a:xfrm>
-            <a:off x="9464040" y="2194560"/>
-            <a:ext cx="1965960" cy="411480"/>
-          </a:xfrm>
-          <a:prstGeom prst="rect">
-            <a:avLst/>
-          </a:prstGeom>
-          <a:noFill/>
-          <a:ln/>
-        </p:spPr>
-        <p:txBody>
-          <a:bodyPr wrap="square" lIns="0" tIns="0" rIns="0" bIns="0" rtlCol="0" anchor="t"/>
-          <a:lstStyle/>
-          <a:p>
-            <a:pPr indent="0" marL="0">
-              <a:buNone/>
-            </a:pPr>
-            <a:r>
-              <a:rPr lang="en-US" sz="1600" b="1" dirty="0">
+              <a:rPr lang="en-US" sz="1400" dirty="0">
                 <a:solidFill>
                   <a:schemeClr val="tx1"/>
                 </a:solidFill>
               </a:rPr>
-              <a:t>Graph sanity</a:t>
-            </a:r>
-            <a:endParaRPr lang="en-US" sz="1600" dirty="0"/>
-          </a:p>
-        </p:txBody>
-      </p:sp>
-      <p:sp>
-        <p:nvSpPr>
-          <p:cNvPr id="19" name="Text 16"/>
-          <p:cNvSpPr txBox="1"/>
-          <p:nvPr/>
-        </p:nvSpPr>
-        <p:spPr>
-          <a:xfrm>
-            <a:off x="9464040" y="2606040"/>
-            <a:ext cx="1965960" cy="1005840"/>
-          </a:xfrm>
-          <a:prstGeom prst="rect">
-            <a:avLst/>
-          </a:prstGeom>
-          <a:noFill/>
-          <a:ln/>
-        </p:spPr>
-        <p:txBody>
-          <a:bodyPr wrap="square" lIns="0" tIns="0" rIns="0" bIns="0" rtlCol="0" anchor="t"/>
-          <a:lstStyle/>
-          <a:p>
-            <a:pPr indent="0" marL="0">
-              <a:buNone/>
-            </a:pPr>
-            <a:r>
-              <a:rPr lang="en-US" sz="1300" dirty="0">
-                <a:solidFill>
-                  <a:schemeClr val="tx1"/>
-                </a:solidFill>
-              </a:rPr>
-              <a:t>PageRank top movie is popular; communities add up</a:t>
-            </a:r>
-            <a:endParaRPr lang="en-US" sz="1300" dirty="0"/>
-          </a:p>
-        </p:txBody>
-      </p:sp>
-      <p:sp>
-        <p:nvSpPr>
-          <p:cNvPr id="20" name="Shape 17"/>
-          <p:cNvSpPr/>
-          <p:nvPr/>
-        </p:nvSpPr>
-        <p:spPr>
-          <a:xfrm>
-            <a:off x="4114800" y="3886200"/>
-            <a:ext cx="2331720" cy="2331720"/>
-          </a:xfrm>
-          <a:prstGeom prst="roundRect">
-            <a:avLst>
-              <a:gd name="adj" fmla="val 3137"/>
-            </a:avLst>
-          </a:prstGeom>
-          <a:solidFill>
-            <a:schemeClr val="bg2"/>
-          </a:solidFill>
-          <a:ln/>
-        </p:spPr>
-      </p:sp>
-      <p:sp>
-        <p:nvSpPr>
-          <p:cNvPr id="21" name="Text 18"/>
-          <p:cNvSpPr txBox="1"/>
-          <p:nvPr/>
-        </p:nvSpPr>
-        <p:spPr>
-          <a:xfrm>
-            <a:off x="4297680" y="4023360"/>
-            <a:ext cx="1965960" cy="685800"/>
-          </a:xfrm>
-          <a:prstGeom prst="rect">
-            <a:avLst/>
-          </a:prstGeom>
-          <a:noFill/>
-          <a:ln/>
-        </p:spPr>
-        <p:txBody>
-          <a:bodyPr wrap="square" lIns="0" tIns="0" rIns="0" bIns="0" rtlCol="0" anchor="t"/>
-          <a:lstStyle/>
-          <a:p>
-            <a:pPr indent="0" marL="0">
-              <a:buNone/>
-            </a:pPr>
-            <a:r>
-              <a:rPr lang="en-US" sz="3600" b="1" dirty="0">
-                <a:solidFill>
-                  <a:schemeClr val="accent4"/>
-                </a:solidFill>
-              </a:rPr>
-              <a:t>7</a:t>
-            </a:r>
-            <a:endParaRPr lang="en-US" sz="3600" dirty="0"/>
-          </a:p>
-        </p:txBody>
-      </p:sp>
-      <p:sp>
-        <p:nvSpPr>
-          <p:cNvPr id="22" name="Text 19"/>
-          <p:cNvSpPr txBox="1"/>
-          <p:nvPr/>
-        </p:nvSpPr>
-        <p:spPr>
-          <a:xfrm>
-            <a:off x="4297680" y="4709160"/>
-            <a:ext cx="1965960" cy="411480"/>
-          </a:xfrm>
-          <a:prstGeom prst="rect">
-            <a:avLst/>
-          </a:prstGeom>
-          <a:noFill/>
-          <a:ln/>
-        </p:spPr>
-        <p:txBody>
-          <a:bodyPr wrap="square" lIns="0" tIns="0" rIns="0" bIns="0" rtlCol="0" anchor="t"/>
-          <a:lstStyle/>
-          <a:p>
-            <a:pPr indent="0" marL="0">
-              <a:buNone/>
-            </a:pPr>
-            <a:r>
-              <a:rPr lang="en-US" sz="1600" b="1" dirty="0">
-                <a:solidFill>
-                  <a:schemeClr val="tx1"/>
-                </a:solidFill>
-              </a:rPr>
-              <a:t>Beats baselines</a:t>
-            </a:r>
-            <a:endParaRPr lang="en-US" sz="1600" dirty="0"/>
-          </a:p>
-        </p:txBody>
-      </p:sp>
-      <p:sp>
-        <p:nvSpPr>
-          <p:cNvPr id="23" name="Text 20"/>
-          <p:cNvSpPr txBox="1"/>
-          <p:nvPr/>
-        </p:nvSpPr>
-        <p:spPr>
-          <a:xfrm>
-            <a:off x="4297680" y="5120640"/>
-            <a:ext cx="1965960" cy="1005840"/>
-          </a:xfrm>
-          <a:prstGeom prst="rect">
-            <a:avLst/>
-          </a:prstGeom>
-          <a:noFill/>
-          <a:ln/>
-        </p:spPr>
-        <p:txBody>
-          <a:bodyPr wrap="square" lIns="0" tIns="0" rIns="0" bIns="0" rtlCol="0" anchor="t"/>
-          <a:lstStyle/>
-          <a:p>
-            <a:pPr indent="0" marL="0">
-              <a:buNone/>
-            </a:pPr>
-            <a:r>
-              <a:rPr lang="en-US" sz="1300" dirty="0">
-                <a:solidFill>
-                  <a:schemeClr val="tx1"/>
-                </a:solidFill>
-              </a:rPr>
-              <a:t>RMSE below both baselines; ranking above popularity</a:t>
-            </a:r>
-            <a:endParaRPr lang="en-US" sz="1300" dirty="0"/>
-          </a:p>
-        </p:txBody>
-      </p:sp>
-      <p:sp>
-        <p:nvSpPr>
-          <p:cNvPr id="24" name="Shape 21"/>
-          <p:cNvSpPr/>
-          <p:nvPr/>
-        </p:nvSpPr>
-        <p:spPr>
-          <a:xfrm>
-            <a:off x="6697980" y="3886200"/>
-            <a:ext cx="2331720" cy="2331720"/>
-          </a:xfrm>
-          <a:prstGeom prst="roundRect">
-            <a:avLst>
-              <a:gd name="adj" fmla="val 3137"/>
-            </a:avLst>
-          </a:prstGeom>
-          <a:solidFill>
-            <a:schemeClr val="bg2"/>
-          </a:solidFill>
-          <a:ln/>
-        </p:spPr>
-      </p:sp>
-      <p:sp>
-        <p:nvSpPr>
-          <p:cNvPr id="25" name="Text 22"/>
-          <p:cNvSpPr txBox="1"/>
-          <p:nvPr/>
-        </p:nvSpPr>
-        <p:spPr>
-          <a:xfrm>
-            <a:off x="6880860" y="4023360"/>
-            <a:ext cx="1965960" cy="685800"/>
-          </a:xfrm>
-          <a:prstGeom prst="rect">
-            <a:avLst/>
-          </a:prstGeom>
-          <a:noFill/>
-          <a:ln/>
-        </p:spPr>
-        <p:txBody>
-          <a:bodyPr wrap="square" lIns="0" tIns="0" rIns="0" bIns="0" rtlCol="0" anchor="t"/>
-          <a:lstStyle/>
-          <a:p>
-            <a:pPr indent="0" marL="0">
-              <a:buNone/>
-            </a:pPr>
-            <a:r>
-              <a:rPr lang="en-US" sz="3600" b="1" dirty="0">
-                <a:solidFill>
-                  <a:schemeClr val="accent4"/>
-                </a:solidFill>
-              </a:rPr>
-              <a:t>4</a:t>
-            </a:r>
-            <a:endParaRPr lang="en-US" sz="3600" dirty="0"/>
-          </a:p>
-        </p:txBody>
-      </p:sp>
-      <p:sp>
-        <p:nvSpPr>
-          <p:cNvPr id="26" name="Text 23"/>
-          <p:cNvSpPr txBox="1"/>
-          <p:nvPr/>
-        </p:nvSpPr>
-        <p:spPr>
-          <a:xfrm>
-            <a:off x="6880860" y="4709160"/>
-            <a:ext cx="1965960" cy="411480"/>
-          </a:xfrm>
-          <a:prstGeom prst="rect">
-            <a:avLst/>
-          </a:prstGeom>
-          <a:noFill/>
-          <a:ln/>
-        </p:spPr>
-        <p:txBody>
-          <a:bodyPr wrap="square" lIns="0" tIns="0" rIns="0" bIns="0" rtlCol="0" anchor="t"/>
-          <a:lstStyle/>
-          <a:p>
-            <a:pPr indent="0" marL="0">
-              <a:buNone/>
-            </a:pPr>
-            <a:r>
-              <a:rPr lang="en-US" sz="1600" b="1" dirty="0">
-                <a:solidFill>
-                  <a:schemeClr val="tx1"/>
-                </a:solidFill>
-              </a:rPr>
-              <a:t>Recommendations</a:t>
-            </a:r>
-            <a:endParaRPr lang="en-US" sz="1600" dirty="0"/>
-          </a:p>
-        </p:txBody>
-      </p:sp>
-      <p:sp>
-        <p:nvSpPr>
-          <p:cNvPr id="27" name="Text 24"/>
-          <p:cNvSpPr txBox="1"/>
-          <p:nvPr/>
-        </p:nvSpPr>
-        <p:spPr>
-          <a:xfrm>
-            <a:off x="6880860" y="5120640"/>
-            <a:ext cx="1965960" cy="1005840"/>
-          </a:xfrm>
-          <a:prstGeom prst="rect">
-            <a:avLst/>
-          </a:prstGeom>
-          <a:noFill/>
-          <a:ln/>
-        </p:spPr>
-        <p:txBody>
-          <a:bodyPr wrap="square" lIns="0" tIns="0" rIns="0" bIns="0" rtlCol="0" anchor="t"/>
-          <a:lstStyle/>
-          <a:p>
-            <a:pPr indent="0" marL="0">
-              <a:buNone/>
-            </a:pPr>
-            <a:r>
-              <a:rPr lang="en-US" sz="1300" dirty="0">
-                <a:solidFill>
-                  <a:schemeClr val="tx1"/>
-                </a:solidFill>
-              </a:rPr>
-              <a:t>10 unique, unseen, each with ≥ 20 ratings</a:t>
-            </a:r>
-            <a:endParaRPr lang="en-US" sz="1300" dirty="0"/>
-          </a:p>
-        </p:txBody>
-      </p:sp>
-      <p:sp>
-        <p:nvSpPr>
-          <p:cNvPr id="28" name="Shape 25"/>
-          <p:cNvSpPr/>
-          <p:nvPr/>
-        </p:nvSpPr>
-        <p:spPr>
-          <a:xfrm>
-            <a:off x="9281160" y="3886200"/>
-            <a:ext cx="2331720" cy="2331720"/>
-          </a:xfrm>
-          <a:prstGeom prst="roundRect">
-            <a:avLst>
-              <a:gd name="adj" fmla="val 3137"/>
-            </a:avLst>
-          </a:prstGeom>
-          <a:solidFill>
-            <a:schemeClr val="bg2"/>
-          </a:solidFill>
-          <a:ln/>
-        </p:spPr>
-      </p:sp>
-      <p:sp>
-        <p:nvSpPr>
-          <p:cNvPr id="29" name="Text 26"/>
-          <p:cNvSpPr txBox="1"/>
-          <p:nvPr/>
-        </p:nvSpPr>
-        <p:spPr>
-          <a:xfrm>
-            <a:off x="9464040" y="4023360"/>
-            <a:ext cx="1965960" cy="685800"/>
-          </a:xfrm>
-          <a:prstGeom prst="rect">
-            <a:avLst/>
-          </a:prstGeom>
-          <a:noFill/>
-          <a:ln/>
-        </p:spPr>
-        <p:txBody>
-          <a:bodyPr wrap="square" lIns="0" tIns="0" rIns="0" bIns="0" rtlCol="0" anchor="t"/>
-          <a:lstStyle/>
-          <a:p>
-            <a:pPr indent="0" marL="0">
-              <a:buNone/>
-            </a:pPr>
-            <a:r>
-              <a:rPr lang="en-US" sz="3600" b="1" dirty="0">
-                <a:solidFill>
-                  <a:schemeClr val="accent4"/>
-                </a:solidFill>
-              </a:rPr>
-              <a:t>2</a:t>
-            </a:r>
-            <a:endParaRPr lang="en-US" sz="3600" dirty="0"/>
-          </a:p>
-        </p:txBody>
-      </p:sp>
-      <p:sp>
-        <p:nvSpPr>
-          <p:cNvPr id="30" name="Text 27"/>
-          <p:cNvSpPr txBox="1"/>
-          <p:nvPr/>
-        </p:nvSpPr>
-        <p:spPr>
-          <a:xfrm>
-            <a:off x="9464040" y="4709160"/>
-            <a:ext cx="1965960" cy="411480"/>
-          </a:xfrm>
-          <a:prstGeom prst="rect">
-            <a:avLst/>
-          </a:prstGeom>
-          <a:noFill/>
-          <a:ln/>
-        </p:spPr>
-        <p:txBody>
-          <a:bodyPr wrap="square" lIns="0" tIns="0" rIns="0" bIns="0" rtlCol="0" anchor="t"/>
-          <a:lstStyle/>
-          <a:p>
-            <a:pPr indent="0" marL="0">
-              <a:buNone/>
-            </a:pPr>
-            <a:r>
-              <a:rPr lang="en-US" sz="1600" b="1" dirty="0">
-                <a:solidFill>
-                  <a:schemeClr val="tx1"/>
-                </a:solidFill>
-              </a:rPr>
-              <a:t>Scalability trends</a:t>
-            </a:r>
-            <a:endParaRPr lang="en-US" sz="1600" dirty="0"/>
-          </a:p>
-        </p:txBody>
-      </p:sp>
-      <p:sp>
-        <p:nvSpPr>
-          <p:cNvPr id="31" name="Text 28"/>
-          <p:cNvSpPr txBox="1"/>
-          <p:nvPr/>
-        </p:nvSpPr>
-        <p:spPr>
-          <a:xfrm>
-            <a:off x="9464040" y="5120640"/>
-            <a:ext cx="1965960" cy="1005840"/>
-          </a:xfrm>
-          <a:prstGeom prst="rect">
-            <a:avLst/>
-          </a:prstGeom>
-          <a:noFill/>
-          <a:ln/>
-        </p:spPr>
-        <p:txBody>
-          <a:bodyPr wrap="square" lIns="0" tIns="0" rIns="0" bIns="0" rtlCol="0" anchor="t"/>
-          <a:lstStyle/>
-          <a:p>
-            <a:pPr indent="0" marL="0">
-              <a:buNone/>
-            </a:pPr>
-            <a:r>
-              <a:rPr lang="en-US" sz="1300" dirty="0">
-                <a:solidFill>
-                  <a:schemeClr val="tx1"/>
-                </a:solidFill>
-              </a:rPr>
-              <a:t>more cores → faster ALS; more data → lower RMSE</a:t>
-            </a:r>
-            <a:endParaRPr lang="en-US" sz="1300" dirty="0"/>
+              <a:t>More data → lower error: RMSE 1.012 → 0.881</a:t>
+            </a:r>
+            <a:endParaRPr lang="en-US" sz="1400" dirty="0"/>
           </a:p>
         </p:txBody>
       </p:sp>
@@ -15116,7 +14521,7 @@
                   <a:schemeClr val="tx1"/>
                 </a:solidFill>
               </a:rPr>
-              <a:t>Challenges and solutions</a:t>
+              <a:t>Execution time per stage</a:t>
             </a:r>
             <a:endParaRPr lang="en-US" sz="3600" dirty="0"/>
           </a:p>
@@ -15124,7 +14529,1445 @@
       </p:sp>
       <p:graphicFrame>
         <p:nvGraphicFramePr>
-          <p:cNvPr id="21" name="Table 0"/>
+          <p:cNvPr id="4" name="Chart 0" descr=""/>
+          <p:cNvGraphicFramePr/>
+          <p:nvPr/>
+        </p:nvGraphicFramePr>
+        <p:xfrm>
+          <a:off x="548640" y="1325880"/>
+          <a:ext cx="7315200" cy="4892040"/>
+        </p:xfrm>
+        <a:graphic xmlns:a="http://schemas.openxmlformats.org/drawingml/2006/main">
+          <a:graphicData uri="http://schemas.openxmlformats.org/drawingml/2006/chart">
+            <c:chart xmlns:c="http://schemas.openxmlformats.org/drawingml/2006/chart" r:id="rId1"/>
+          </a:graphicData>
+        </a:graphic>
+      </p:graphicFrame>
+      <p:sp>
+        <p:nvSpPr>
+          <p:cNvPr id="5" name="Shape 1"/>
+          <p:cNvSpPr/>
+          <p:nvPr/>
+        </p:nvSpPr>
+        <p:spPr>
+          <a:xfrm>
+            <a:off x="8138160" y="1325880"/>
+            <a:ext cx="3474720" cy="1508760"/>
+          </a:xfrm>
+          <a:prstGeom prst="roundRect">
+            <a:avLst>
+              <a:gd name="adj" fmla="val 4848"/>
+            </a:avLst>
+          </a:prstGeom>
+          <a:solidFill>
+            <a:schemeClr val="bg2"/>
+          </a:solidFill>
+          <a:ln/>
+        </p:spPr>
+      </p:sp>
+      <p:sp>
+        <p:nvSpPr>
+          <p:cNvPr id="6" name="Text 2"/>
+          <p:cNvSpPr txBox="1"/>
+          <p:nvPr/>
+        </p:nvSpPr>
+        <p:spPr>
+          <a:xfrm>
+            <a:off x="8366760" y="1508760"/>
+            <a:ext cx="3017520" cy="685800"/>
+          </a:xfrm>
+          <a:prstGeom prst="rect">
+            <a:avLst/>
+          </a:prstGeom>
+          <a:noFill/>
+          <a:ln/>
+        </p:spPr>
+        <p:txBody>
+          <a:bodyPr wrap="square" lIns="0" tIns="0" rIns="0" bIns="0" rtlCol="0" anchor="ctr"/>
+          <a:lstStyle/>
+          <a:p>
+            <a:pPr indent="0" marL="0">
+              <a:buNone/>
+            </a:pPr>
+            <a:r>
+              <a:rPr lang="en-US" sz="3600" b="1" dirty="0">
+                <a:solidFill>
+                  <a:schemeClr val="accent2"/>
+                </a:solidFill>
+              </a:rPr>
+              <a:t>7.8 min</a:t>
+            </a:r>
+            <a:endParaRPr lang="en-US" sz="3600" dirty="0"/>
+          </a:p>
+        </p:txBody>
+      </p:sp>
+      <p:sp>
+        <p:nvSpPr>
+          <p:cNvPr id="7" name="Text 3"/>
+          <p:cNvSpPr txBox="1"/>
+          <p:nvPr/>
+        </p:nvSpPr>
+        <p:spPr>
+          <a:xfrm>
+            <a:off x="8366760" y="2221992"/>
+            <a:ext cx="3017520" cy="457200"/>
+          </a:xfrm>
+          <a:prstGeom prst="rect">
+            <a:avLst/>
+          </a:prstGeom>
+          <a:noFill/>
+          <a:ln/>
+        </p:spPr>
+        <p:txBody>
+          <a:bodyPr wrap="square" lIns="0" tIns="0" rIns="0" bIns="0" rtlCol="0" anchor="t"/>
+          <a:lstStyle/>
+          <a:p>
+            <a:pPr indent="0" marL="0">
+              <a:buNone/>
+            </a:pPr>
+            <a:r>
+              <a:rPr lang="en-US" sz="1400" dirty="0">
+                <a:solidFill>
+                  <a:schemeClr val="tx1"/>
+                </a:solidFill>
+              </a:rPr>
+              <a:t>for the whole pipeline, all 11 stages</a:t>
+            </a:r>
+            <a:endParaRPr lang="en-US" sz="1400" dirty="0"/>
+          </a:p>
+        </p:txBody>
+      </p:sp>
+      <p:sp>
+        <p:nvSpPr>
+          <p:cNvPr id="8" name="Shape 4"/>
+          <p:cNvSpPr/>
+          <p:nvPr/>
+        </p:nvSpPr>
+        <p:spPr>
+          <a:xfrm>
+            <a:off x="8138160" y="3017520"/>
+            <a:ext cx="3474720" cy="1508760"/>
+          </a:xfrm>
+          <a:prstGeom prst="roundRect">
+            <a:avLst>
+              <a:gd name="adj" fmla="val 4848"/>
+            </a:avLst>
+          </a:prstGeom>
+          <a:solidFill>
+            <a:schemeClr val="bg2"/>
+          </a:solidFill>
+          <a:ln/>
+        </p:spPr>
+      </p:sp>
+      <p:sp>
+        <p:nvSpPr>
+          <p:cNvPr id="9" name="Text 5"/>
+          <p:cNvSpPr txBox="1"/>
+          <p:nvPr/>
+        </p:nvSpPr>
+        <p:spPr>
+          <a:xfrm>
+            <a:off x="8366760" y="3200400"/>
+            <a:ext cx="3017520" cy="685800"/>
+          </a:xfrm>
+          <a:prstGeom prst="rect">
+            <a:avLst/>
+          </a:prstGeom>
+          <a:noFill/>
+          <a:ln/>
+        </p:spPr>
+        <p:txBody>
+          <a:bodyPr wrap="square" lIns="0" tIns="0" rIns="0" bIns="0" rtlCol="0" anchor="ctr"/>
+          <a:lstStyle/>
+          <a:p>
+            <a:pPr indent="0" marL="0">
+              <a:buNone/>
+            </a:pPr>
+            <a:r>
+              <a:rPr lang="en-US" sz="3600" b="1" dirty="0">
+                <a:solidFill>
+                  <a:schemeClr val="accent2"/>
+                </a:solidFill>
+              </a:rPr>
+              <a:t>173 s</a:t>
+            </a:r>
+            <a:endParaRPr lang="en-US" sz="3600" dirty="0"/>
+          </a:p>
+        </p:txBody>
+      </p:sp>
+      <p:sp>
+        <p:nvSpPr>
+          <p:cNvPr id="10" name="Text 6"/>
+          <p:cNvSpPr txBox="1"/>
+          <p:nvPr/>
+        </p:nvSpPr>
+        <p:spPr>
+          <a:xfrm>
+            <a:off x="8366760" y="3913632"/>
+            <a:ext cx="3017520" cy="457200"/>
+          </a:xfrm>
+          <a:prstGeom prst="rect">
+            <a:avLst/>
+          </a:prstGeom>
+          <a:noFill/>
+          <a:ln/>
+        </p:spPr>
+        <p:txBody>
+          <a:bodyPr wrap="square" lIns="0" tIns="0" rIns="0" bIns="0" rtlCol="0" anchor="t"/>
+          <a:lstStyle/>
+          <a:p>
+            <a:pPr indent="0" marL="0">
+              <a:buNone/>
+            </a:pPr>
+            <a:r>
+              <a:rPr lang="en-US" sz="1400" dirty="0">
+                <a:solidFill>
+                  <a:schemeClr val="tx1"/>
+                </a:solidFill>
+              </a:rPr>
+              <a:t>Model B tuning: the slowest stage (8 models)</a:t>
+            </a:r>
+            <a:endParaRPr lang="en-US" sz="1400" dirty="0"/>
+          </a:p>
+        </p:txBody>
+      </p:sp>
+      <p:sp>
+        <p:nvSpPr>
+          <p:cNvPr id="11" name="Shape 7"/>
+          <p:cNvSpPr/>
+          <p:nvPr/>
+        </p:nvSpPr>
+        <p:spPr>
+          <a:xfrm>
+            <a:off x="8138160" y="4709160"/>
+            <a:ext cx="3474720" cy="1508760"/>
+          </a:xfrm>
+          <a:prstGeom prst="roundRect">
+            <a:avLst>
+              <a:gd name="adj" fmla="val 4848"/>
+            </a:avLst>
+          </a:prstGeom>
+          <a:solidFill>
+            <a:schemeClr val="bg2"/>
+          </a:solidFill>
+          <a:ln/>
+        </p:spPr>
+      </p:sp>
+      <p:sp>
+        <p:nvSpPr>
+          <p:cNvPr id="12" name="Text 8"/>
+          <p:cNvSpPr txBox="1"/>
+          <p:nvPr/>
+        </p:nvSpPr>
+        <p:spPr>
+          <a:xfrm>
+            <a:off x="8366760" y="4892040"/>
+            <a:ext cx="3017520" cy="685800"/>
+          </a:xfrm>
+          <a:prstGeom prst="rect">
+            <a:avLst/>
+          </a:prstGeom>
+          <a:noFill/>
+          <a:ln/>
+        </p:spPr>
+        <p:txBody>
+          <a:bodyPr wrap="square" lIns="0" tIns="0" rIns="0" bIns="0" rtlCol="0" anchor="ctr"/>
+          <a:lstStyle/>
+          <a:p>
+            <a:pPr indent="0" marL="0">
+              <a:buNone/>
+            </a:pPr>
+            <a:r>
+              <a:rPr lang="en-US" sz="3600" b="1" dirty="0">
+                <a:solidFill>
+                  <a:schemeClr val="accent4"/>
+                </a:solidFill>
+              </a:rPr>
+              <a:t>4.6 s</a:t>
+            </a:r>
+            <a:endParaRPr lang="en-US" sz="3600" dirty="0"/>
+          </a:p>
+        </p:txBody>
+      </p:sp>
+      <p:sp>
+        <p:nvSpPr>
+          <p:cNvPr id="13" name="Text 9"/>
+          <p:cNvSpPr txBox="1"/>
+          <p:nvPr/>
+        </p:nvSpPr>
+        <p:spPr>
+          <a:xfrm>
+            <a:off x="8366760" y="5605272"/>
+            <a:ext cx="3017520" cy="457200"/>
+          </a:xfrm>
+          <a:prstGeom prst="rect">
+            <a:avLst/>
+          </a:prstGeom>
+          <a:noFill/>
+          <a:ln/>
+        </p:spPr>
+        <p:txBody>
+          <a:bodyPr wrap="square" lIns="0" tIns="0" rIns="0" bIns="0" rtlCol="0" anchor="t"/>
+          <a:lstStyle/>
+          <a:p>
+            <a:pPr indent="0" marL="0">
+              <a:buNone/>
+            </a:pPr>
+            <a:r>
+              <a:rPr lang="en-US" sz="1400" dirty="0">
+                <a:solidFill>
+                  <a:schemeClr val="tx1"/>
+                </a:solidFill>
+              </a:rPr>
+              <a:t>to train one ALS model on 80,886 ratings</a:t>
+            </a:r>
+            <a:endParaRPr lang="en-US" sz="1400" dirty="0"/>
+          </a:p>
+        </p:txBody>
+      </p:sp>
+      <p:sp>
+        <p:nvSpPr>
+          <p:cNvPr id="25" name="Slide Number Placeholder 0"/>
+          <p:cNvSpPr>
+            <a:spLocks noGrp="1"/>
+          </p:cNvSpPr>
+          <p:nvPr>
+            <p:ph type="sldNum" sz="quarter" idx="4294967295"/>
+          </p:nvPr>
+        </p:nvSpPr>
+        <p:spPr>
+          <a:xfrm>
+            <a:off x="11155680" y="6400800"/>
+            <a:ext cx="457200" cy="274320"/>
+          </a:xfrm>
+          <a:prstGeom prst="rect">
+            <a:avLst/>
+          </a:prstGeom>
+          <a:extLst>
+            <a:ext uri="{C572A759-6A51-4108-AA02-DFA0A04FC94B}">
+              <ma14:wrappingTextBoxFlag xmlns:ma14="http://schemas.microsoft.com/office/mac/drawingml/2011/main" val="0"/>
+            </a:ext>
+          </a:extLst>
+        </p:spPr>
+        <p:txBody>
+          <a:bodyPr/>
+          <a:lstStyle>
+            <a:lvl1pPr>
+              <a:defRPr sz="1000">
+                <a:solidFill>
+                  <a:srgbClr val="8D99AE"/>
+                </a:solidFill>
+              </a:defRPr>
+            </a:lvl1pPr>
+          </a:lstStyle>
+          <a:p>
+            <a:pPr algn="r"/>
+            <a:fld id="{F7021451-1387-4CA6-816F-3879F97B5CBC}" type="slidenum">
+              <a:rPr b="0" lang="en-US"/>
+              <a:t>20</a:t>
+            </a:fld>
+            <a:endParaRPr lang="en-US"/>
+          </a:p>
+        </p:txBody>
+      </p:sp>
+    </p:spTree>
+  </p:cSld>
+  <p:clrMapOvr>
+    <a:masterClrMapping/>
+  </p:clrMapOvr>
+</p:sld>
+</file>
+
+<file path=ppt/slides/slide21.xml><?xml version="1.0" encoding="utf-8"?>
+<p:sld xmlns:a="http://schemas.openxmlformats.org/drawingml/2006/main" xmlns:r="http://schemas.openxmlformats.org/officeDocument/2006/relationships" xmlns:p="http://schemas.openxmlformats.org/presentationml/2006/main">
+  <p:cSld name="Slide 21">
+    <p:spTree>
+      <p:nvGrpSpPr>
+        <p:cNvPr id="1" name=""/>
+        <p:cNvGrpSpPr/>
+        <p:nvPr/>
+      </p:nvGrpSpPr>
+      <p:grpSpPr>
+        <a:xfrm>
+          <a:off x="0" y="0"/>
+          <a:ext cx="0" cy="0"/>
+          <a:chOff x="0" y="0"/>
+          <a:chExt cx="0" cy="0"/>
+        </a:xfrm>
+      </p:grpSpPr>
+      <p:sp>
+        <p:nvSpPr>
+          <p:cNvPr id="2" name="Text 0"/>
+          <p:cNvSpPr/>
+          <p:nvPr>
+            <p:ph idx="100" type="title" hasCustomPrompt="1"/>
+          </p:nvPr>
+        </p:nvSpPr>
+        <p:spPr>
+          <a:xfrm>
+            <a:off x="548640" y="320040"/>
+            <a:ext cx="11064240" cy="777240"/>
+          </a:xfrm>
+          <a:prstGeom prst="rect">
+            <a:avLst/>
+          </a:prstGeom>
+          <a:noFill/>
+          <a:ln/>
+        </p:spPr>
+        <p:txBody>
+          <a:bodyPr wrap="square" lIns="0" tIns="0" rIns="0" bIns="0" rtlCol="0" anchor="ctr"/>
+          <a:lstStyle/>
+          <a:p>
+            <a:pPr indent="0" marL="0">
+              <a:buNone/>
+            </a:pPr>
+            <a:r>
+              <a:rPr lang="en-US" sz="3600" b="1" dirty="0">
+                <a:solidFill>
+                  <a:schemeClr val="tx1"/>
+                </a:solidFill>
+              </a:rPr>
+              <a:t>Verification: 29 automated checks</a:t>
+            </a:r>
+            <a:endParaRPr lang="en-US" sz="3600" dirty="0"/>
+          </a:p>
+        </p:txBody>
+      </p:sp>
+      <p:sp>
+        <p:nvSpPr>
+          <p:cNvPr id="4" name="Shape 1"/>
+          <p:cNvSpPr/>
+          <p:nvPr/>
+        </p:nvSpPr>
+        <p:spPr>
+          <a:xfrm>
+            <a:off x="548640" y="1371600"/>
+            <a:ext cx="3291840" cy="4846320"/>
+          </a:xfrm>
+          <a:prstGeom prst="roundRect">
+            <a:avLst>
+              <a:gd name="adj" fmla="val 2222"/>
+            </a:avLst>
+          </a:prstGeom>
+          <a:solidFill>
+            <a:schemeClr val="tx2"/>
+          </a:solidFill>
+          <a:ln/>
+        </p:spPr>
+      </p:sp>
+      <p:sp>
+        <p:nvSpPr>
+          <p:cNvPr id="5" name="Text 2"/>
+          <p:cNvSpPr txBox="1"/>
+          <p:nvPr/>
+        </p:nvSpPr>
+        <p:spPr>
+          <a:xfrm>
+            <a:off x="777240" y="2011680"/>
+            <a:ext cx="2834640" cy="1005840"/>
+          </a:xfrm>
+          <a:prstGeom prst="rect">
+            <a:avLst/>
+          </a:prstGeom>
+          <a:noFill/>
+          <a:ln/>
+        </p:spPr>
+        <p:txBody>
+          <a:bodyPr wrap="square" lIns="0" tIns="0" rIns="0" bIns="0" rtlCol="0" anchor="t"/>
+          <a:lstStyle/>
+          <a:p>
+            <a:pPr algn="ctr" indent="0" marL="0">
+              <a:buNone/>
+            </a:pPr>
+            <a:r>
+              <a:rPr lang="en-US" sz="5400" b="1" dirty="0">
+                <a:solidFill>
+                  <a:schemeClr val="accent1"/>
+                </a:solidFill>
+              </a:rPr>
+              <a:t>29/29</a:t>
+            </a:r>
+            <a:endParaRPr lang="en-US" sz="5400" dirty="0"/>
+          </a:p>
+        </p:txBody>
+      </p:sp>
+      <p:sp>
+        <p:nvSpPr>
+          <p:cNvPr id="6" name="Text 3"/>
+          <p:cNvSpPr txBox="1"/>
+          <p:nvPr/>
+        </p:nvSpPr>
+        <p:spPr>
+          <a:xfrm>
+            <a:off x="777240" y="3063240"/>
+            <a:ext cx="2834640" cy="822960"/>
+          </a:xfrm>
+          <a:prstGeom prst="rect">
+            <a:avLst/>
+          </a:prstGeom>
+          <a:noFill/>
+          <a:ln/>
+        </p:spPr>
+        <p:txBody>
+          <a:bodyPr wrap="square" lIns="0" tIns="0" rIns="0" bIns="0" rtlCol="0" anchor="t"/>
+          <a:lstStyle/>
+          <a:p>
+            <a:pPr algn="ctr" indent="0" marL="0">
+              <a:buNone/>
+            </a:pPr>
+            <a:r>
+              <a:rPr lang="en-US" sz="1600" dirty="0">
+                <a:solidFill>
+                  <a:schemeClr val="bg1"/>
+                </a:solidFill>
+              </a:rPr>
+              <a:t>checks passed</a:t>
+            </a:r>
+            <a:endParaRPr lang="en-US" sz="1600" dirty="0"/>
+          </a:p>
+          <a:p>
+            <a:pPr algn="ctr" indent="0" marL="0">
+              <a:buNone/>
+            </a:pPr>
+            <a:r>
+              <a:rPr lang="en-US" sz="1600" dirty="0">
+                <a:solidFill>
+                  <a:schemeClr val="bg1"/>
+                </a:solidFill>
+              </a:rPr>
+              <a:t>(python verify.py)</a:t>
+            </a:r>
+            <a:endParaRPr lang="en-US" sz="1600" dirty="0"/>
+          </a:p>
+        </p:txBody>
+      </p:sp>
+      <p:sp>
+        <p:nvSpPr>
+          <p:cNvPr id="7" name="Text 4"/>
+          <p:cNvSpPr txBox="1"/>
+          <p:nvPr/>
+        </p:nvSpPr>
+        <p:spPr>
+          <a:xfrm>
+            <a:off x="777240" y="4343400"/>
+            <a:ext cx="2834640" cy="1188720"/>
+          </a:xfrm>
+          <a:prstGeom prst="rect">
+            <a:avLst/>
+          </a:prstGeom>
+          <a:noFill/>
+          <a:ln/>
+        </p:spPr>
+        <p:txBody>
+          <a:bodyPr wrap="square" lIns="0" tIns="0" rIns="0" bIns="0" rtlCol="0" anchor="t"/>
+          <a:lstStyle/>
+          <a:p>
+            <a:pPr algn="ctr" indent="0" marL="0">
+              <a:buNone/>
+            </a:pPr>
+            <a:r>
+              <a:rPr lang="en-US" sz="1400" dirty="0">
+                <a:solidFill>
+                  <a:schemeClr val="accent5"/>
+                </a:solidFill>
+              </a:rPr>
+              <a:t>Spark results recounted with plain pandas, without Spark</a:t>
+            </a:r>
+            <a:endParaRPr lang="en-US" sz="1400" dirty="0"/>
+          </a:p>
+        </p:txBody>
+      </p:sp>
+      <p:sp>
+        <p:nvSpPr>
+          <p:cNvPr id="8" name="Shape 5"/>
+          <p:cNvSpPr/>
+          <p:nvPr/>
+        </p:nvSpPr>
+        <p:spPr>
+          <a:xfrm>
+            <a:off x="4114800" y="1371600"/>
+            <a:ext cx="2331720" cy="2331720"/>
+          </a:xfrm>
+          <a:prstGeom prst="roundRect">
+            <a:avLst>
+              <a:gd name="adj" fmla="val 3137"/>
+            </a:avLst>
+          </a:prstGeom>
+          <a:solidFill>
+            <a:schemeClr val="bg2"/>
+          </a:solidFill>
+          <a:ln/>
+        </p:spPr>
+      </p:sp>
+      <p:sp>
+        <p:nvSpPr>
+          <p:cNvPr id="9" name="Text 6"/>
+          <p:cNvSpPr txBox="1"/>
+          <p:nvPr/>
+        </p:nvSpPr>
+        <p:spPr>
+          <a:xfrm>
+            <a:off x="4297680" y="1508760"/>
+            <a:ext cx="1965960" cy="685800"/>
+          </a:xfrm>
+          <a:prstGeom prst="rect">
+            <a:avLst/>
+          </a:prstGeom>
+          <a:noFill/>
+          <a:ln/>
+        </p:spPr>
+        <p:txBody>
+          <a:bodyPr wrap="square" lIns="0" tIns="0" rIns="0" bIns="0" rtlCol="0" anchor="t"/>
+          <a:lstStyle/>
+          <a:p>
+            <a:pPr indent="0" marL="0">
+              <a:buNone/>
+            </a:pPr>
+            <a:r>
+              <a:rPr lang="en-US" sz="3600" b="1" dirty="0">
+                <a:solidFill>
+                  <a:schemeClr val="accent4"/>
+                </a:solidFill>
+              </a:rPr>
+              <a:t>3</a:t>
+            </a:r>
+            <a:endParaRPr lang="en-US" sz="3600" dirty="0"/>
+          </a:p>
+        </p:txBody>
+      </p:sp>
+      <p:sp>
+        <p:nvSpPr>
+          <p:cNvPr id="10" name="Text 7"/>
+          <p:cNvSpPr txBox="1"/>
+          <p:nvPr/>
+        </p:nvSpPr>
+        <p:spPr>
+          <a:xfrm>
+            <a:off x="4297680" y="2194560"/>
+            <a:ext cx="1965960" cy="411480"/>
+          </a:xfrm>
+          <a:prstGeom prst="rect">
+            <a:avLst/>
+          </a:prstGeom>
+          <a:noFill/>
+          <a:ln/>
+        </p:spPr>
+        <p:txBody>
+          <a:bodyPr wrap="square" lIns="0" tIns="0" rIns="0" bIns="0" rtlCol="0" anchor="t"/>
+          <a:lstStyle/>
+          <a:p>
+            <a:pPr indent="0" marL="0">
+              <a:buNone/>
+            </a:pPr>
+            <a:r>
+              <a:rPr lang="en-US" sz="1600" b="1" dirty="0">
+                <a:solidFill>
+                  <a:schemeClr val="tx1"/>
+                </a:solidFill>
+              </a:rPr>
+              <a:t>Outputs exist</a:t>
+            </a:r>
+            <a:endParaRPr lang="en-US" sz="1600" dirty="0"/>
+          </a:p>
+        </p:txBody>
+      </p:sp>
+      <p:sp>
+        <p:nvSpPr>
+          <p:cNvPr id="11" name="Text 8"/>
+          <p:cNvSpPr txBox="1"/>
+          <p:nvPr/>
+        </p:nvSpPr>
+        <p:spPr>
+          <a:xfrm>
+            <a:off x="4297680" y="2606040"/>
+            <a:ext cx="1965960" cy="1005840"/>
+          </a:xfrm>
+          <a:prstGeom prst="rect">
+            <a:avLst/>
+          </a:prstGeom>
+          <a:noFill/>
+          <a:ln/>
+        </p:spPr>
+        <p:txBody>
+          <a:bodyPr wrap="square" lIns="0" tIns="0" rIns="0" bIns="0" rtlCol="0" anchor="t"/>
+          <a:lstStyle/>
+          <a:p>
+            <a:pPr indent="0" marL="0">
+              <a:buNone/>
+            </a:pPr>
+            <a:r>
+              <a:rPr lang="en-US" sz="1300" dirty="0">
+                <a:solidFill>
+                  <a:schemeClr val="tx1"/>
+                </a:solidFill>
+              </a:rPr>
+              <a:t>metrics, charts and result tables</a:t>
+            </a:r>
+            <a:endParaRPr lang="en-US" sz="1300" dirty="0"/>
+          </a:p>
+        </p:txBody>
+      </p:sp>
+      <p:sp>
+        <p:nvSpPr>
+          <p:cNvPr id="12" name="Shape 9"/>
+          <p:cNvSpPr/>
+          <p:nvPr/>
+        </p:nvSpPr>
+        <p:spPr>
+          <a:xfrm>
+            <a:off x="6697980" y="1371600"/>
+            <a:ext cx="2331720" cy="2331720"/>
+          </a:xfrm>
+          <a:prstGeom prst="roundRect">
+            <a:avLst>
+              <a:gd name="adj" fmla="val 3137"/>
+            </a:avLst>
+          </a:prstGeom>
+          <a:solidFill>
+            <a:schemeClr val="bg2"/>
+          </a:solidFill>
+          <a:ln/>
+        </p:spPr>
+      </p:sp>
+      <p:sp>
+        <p:nvSpPr>
+          <p:cNvPr id="13" name="Text 10"/>
+          <p:cNvSpPr txBox="1"/>
+          <p:nvPr/>
+        </p:nvSpPr>
+        <p:spPr>
+          <a:xfrm>
+            <a:off x="6880860" y="1508760"/>
+            <a:ext cx="1965960" cy="685800"/>
+          </a:xfrm>
+          <a:prstGeom prst="rect">
+            <a:avLst/>
+          </a:prstGeom>
+          <a:noFill/>
+          <a:ln/>
+        </p:spPr>
+        <p:txBody>
+          <a:bodyPr wrap="square" lIns="0" tIns="0" rIns="0" bIns="0" rtlCol="0" anchor="t"/>
+          <a:lstStyle/>
+          <a:p>
+            <a:pPr indent="0" marL="0">
+              <a:buNone/>
+            </a:pPr>
+            <a:r>
+              <a:rPr lang="en-US" sz="3600" b="1" dirty="0">
+                <a:solidFill>
+                  <a:schemeClr val="accent4"/>
+                </a:solidFill>
+              </a:rPr>
+              <a:t>8</a:t>
+            </a:r>
+            <a:endParaRPr lang="en-US" sz="3600" dirty="0"/>
+          </a:p>
+        </p:txBody>
+      </p:sp>
+      <p:sp>
+        <p:nvSpPr>
+          <p:cNvPr id="14" name="Text 11"/>
+          <p:cNvSpPr txBox="1"/>
+          <p:nvPr/>
+        </p:nvSpPr>
+        <p:spPr>
+          <a:xfrm>
+            <a:off x="6880860" y="2194560"/>
+            <a:ext cx="1965960" cy="411480"/>
+          </a:xfrm>
+          <a:prstGeom prst="rect">
+            <a:avLst/>
+          </a:prstGeom>
+          <a:noFill/>
+          <a:ln/>
+        </p:spPr>
+        <p:txBody>
+          <a:bodyPr wrap="square" lIns="0" tIns="0" rIns="0" bIns="0" rtlCol="0" anchor="t"/>
+          <a:lstStyle/>
+          <a:p>
+            <a:pPr indent="0" marL="0">
+              <a:buNone/>
+            </a:pPr>
+            <a:r>
+              <a:rPr lang="en-US" sz="1600" b="1" dirty="0">
+                <a:solidFill>
+                  <a:schemeClr val="tx1"/>
+                </a:solidFill>
+              </a:rPr>
+              <a:t>Matches pandas</a:t>
+            </a:r>
+            <a:endParaRPr lang="en-US" sz="1600" dirty="0"/>
+          </a:p>
+        </p:txBody>
+      </p:sp>
+      <p:sp>
+        <p:nvSpPr>
+          <p:cNvPr id="15" name="Text 12"/>
+          <p:cNvSpPr txBox="1"/>
+          <p:nvPr/>
+        </p:nvSpPr>
+        <p:spPr>
+          <a:xfrm>
+            <a:off x="6880860" y="2606040"/>
+            <a:ext cx="1965960" cy="1005840"/>
+          </a:xfrm>
+          <a:prstGeom prst="rect">
+            <a:avLst/>
+          </a:prstGeom>
+          <a:noFill/>
+          <a:ln/>
+        </p:spPr>
+        <p:txBody>
+          <a:bodyPr wrap="square" lIns="0" tIns="0" rIns="0" bIns="0" rtlCol="0" anchor="t"/>
+          <a:lstStyle/>
+          <a:p>
+            <a:pPr indent="0" marL="0">
+              <a:buNone/>
+            </a:pPr>
+            <a:r>
+              <a:rPr lang="en-US" sz="1300" dirty="0">
+                <a:solidFill>
+                  <a:schemeClr val="tx1"/>
+                </a:solidFill>
+              </a:rPr>
+              <a:t>counts, average rating, top-3 movies, graph size</a:t>
+            </a:r>
+            <a:endParaRPr lang="en-US" sz="1300" dirty="0"/>
+          </a:p>
+        </p:txBody>
+      </p:sp>
+      <p:sp>
+        <p:nvSpPr>
+          <p:cNvPr id="16" name="Shape 13"/>
+          <p:cNvSpPr/>
+          <p:nvPr/>
+        </p:nvSpPr>
+        <p:spPr>
+          <a:xfrm>
+            <a:off x="9281160" y="1371600"/>
+            <a:ext cx="2331720" cy="2331720"/>
+          </a:xfrm>
+          <a:prstGeom prst="roundRect">
+            <a:avLst>
+              <a:gd name="adj" fmla="val 3137"/>
+            </a:avLst>
+          </a:prstGeom>
+          <a:solidFill>
+            <a:schemeClr val="bg2"/>
+          </a:solidFill>
+          <a:ln/>
+        </p:spPr>
+      </p:sp>
+      <p:sp>
+        <p:nvSpPr>
+          <p:cNvPr id="17" name="Text 14"/>
+          <p:cNvSpPr txBox="1"/>
+          <p:nvPr/>
+        </p:nvSpPr>
+        <p:spPr>
+          <a:xfrm>
+            <a:off x="9464040" y="1508760"/>
+            <a:ext cx="1965960" cy="685800"/>
+          </a:xfrm>
+          <a:prstGeom prst="rect">
+            <a:avLst/>
+          </a:prstGeom>
+          <a:noFill/>
+          <a:ln/>
+        </p:spPr>
+        <p:txBody>
+          <a:bodyPr wrap="square" lIns="0" tIns="0" rIns="0" bIns="0" rtlCol="0" anchor="t"/>
+          <a:lstStyle/>
+          <a:p>
+            <a:pPr indent="0" marL="0">
+              <a:buNone/>
+            </a:pPr>
+            <a:r>
+              <a:rPr lang="en-US" sz="3600" b="1" dirty="0">
+                <a:solidFill>
+                  <a:schemeClr val="accent4"/>
+                </a:solidFill>
+              </a:rPr>
+              <a:t>5</a:t>
+            </a:r>
+            <a:endParaRPr lang="en-US" sz="3600" dirty="0"/>
+          </a:p>
+        </p:txBody>
+      </p:sp>
+      <p:sp>
+        <p:nvSpPr>
+          <p:cNvPr id="18" name="Text 15"/>
+          <p:cNvSpPr txBox="1"/>
+          <p:nvPr/>
+        </p:nvSpPr>
+        <p:spPr>
+          <a:xfrm>
+            <a:off x="9464040" y="2194560"/>
+            <a:ext cx="1965960" cy="411480"/>
+          </a:xfrm>
+          <a:prstGeom prst="rect">
+            <a:avLst/>
+          </a:prstGeom>
+          <a:noFill/>
+          <a:ln/>
+        </p:spPr>
+        <p:txBody>
+          <a:bodyPr wrap="square" lIns="0" tIns="0" rIns="0" bIns="0" rtlCol="0" anchor="t"/>
+          <a:lstStyle/>
+          <a:p>
+            <a:pPr indent="0" marL="0">
+              <a:buNone/>
+            </a:pPr>
+            <a:r>
+              <a:rPr lang="en-US" sz="1600" b="1" dirty="0">
+                <a:solidFill>
+                  <a:schemeClr val="tx1"/>
+                </a:solidFill>
+              </a:rPr>
+              <a:t>Graph sanity</a:t>
+            </a:r>
+            <a:endParaRPr lang="en-US" sz="1600" dirty="0"/>
+          </a:p>
+        </p:txBody>
+      </p:sp>
+      <p:sp>
+        <p:nvSpPr>
+          <p:cNvPr id="19" name="Text 16"/>
+          <p:cNvSpPr txBox="1"/>
+          <p:nvPr/>
+        </p:nvSpPr>
+        <p:spPr>
+          <a:xfrm>
+            <a:off x="9464040" y="2606040"/>
+            <a:ext cx="1965960" cy="1005840"/>
+          </a:xfrm>
+          <a:prstGeom prst="rect">
+            <a:avLst/>
+          </a:prstGeom>
+          <a:noFill/>
+          <a:ln/>
+        </p:spPr>
+        <p:txBody>
+          <a:bodyPr wrap="square" lIns="0" tIns="0" rIns="0" bIns="0" rtlCol="0" anchor="t"/>
+          <a:lstStyle/>
+          <a:p>
+            <a:pPr indent="0" marL="0">
+              <a:buNone/>
+            </a:pPr>
+            <a:r>
+              <a:rPr lang="en-US" sz="1300" dirty="0">
+                <a:solidFill>
+                  <a:schemeClr val="tx1"/>
+                </a:solidFill>
+              </a:rPr>
+              <a:t>PageRank top movie is popular; communities add up</a:t>
+            </a:r>
+            <a:endParaRPr lang="en-US" sz="1300" dirty="0"/>
+          </a:p>
+        </p:txBody>
+      </p:sp>
+      <p:sp>
+        <p:nvSpPr>
+          <p:cNvPr id="20" name="Shape 17"/>
+          <p:cNvSpPr/>
+          <p:nvPr/>
+        </p:nvSpPr>
+        <p:spPr>
+          <a:xfrm>
+            <a:off x="4114800" y="3886200"/>
+            <a:ext cx="2331720" cy="2331720"/>
+          </a:xfrm>
+          <a:prstGeom prst="roundRect">
+            <a:avLst>
+              <a:gd name="adj" fmla="val 3137"/>
+            </a:avLst>
+          </a:prstGeom>
+          <a:solidFill>
+            <a:schemeClr val="bg2"/>
+          </a:solidFill>
+          <a:ln/>
+        </p:spPr>
+      </p:sp>
+      <p:sp>
+        <p:nvSpPr>
+          <p:cNvPr id="21" name="Text 18"/>
+          <p:cNvSpPr txBox="1"/>
+          <p:nvPr/>
+        </p:nvSpPr>
+        <p:spPr>
+          <a:xfrm>
+            <a:off x="4297680" y="4023360"/>
+            <a:ext cx="1965960" cy="685800"/>
+          </a:xfrm>
+          <a:prstGeom prst="rect">
+            <a:avLst/>
+          </a:prstGeom>
+          <a:noFill/>
+          <a:ln/>
+        </p:spPr>
+        <p:txBody>
+          <a:bodyPr wrap="square" lIns="0" tIns="0" rIns="0" bIns="0" rtlCol="0" anchor="t"/>
+          <a:lstStyle/>
+          <a:p>
+            <a:pPr indent="0" marL="0">
+              <a:buNone/>
+            </a:pPr>
+            <a:r>
+              <a:rPr lang="en-US" sz="3600" b="1" dirty="0">
+                <a:solidFill>
+                  <a:schemeClr val="accent4"/>
+                </a:solidFill>
+              </a:rPr>
+              <a:t>7</a:t>
+            </a:r>
+            <a:endParaRPr lang="en-US" sz="3600" dirty="0"/>
+          </a:p>
+        </p:txBody>
+      </p:sp>
+      <p:sp>
+        <p:nvSpPr>
+          <p:cNvPr id="22" name="Text 19"/>
+          <p:cNvSpPr txBox="1"/>
+          <p:nvPr/>
+        </p:nvSpPr>
+        <p:spPr>
+          <a:xfrm>
+            <a:off x="4297680" y="4709160"/>
+            <a:ext cx="1965960" cy="411480"/>
+          </a:xfrm>
+          <a:prstGeom prst="rect">
+            <a:avLst/>
+          </a:prstGeom>
+          <a:noFill/>
+          <a:ln/>
+        </p:spPr>
+        <p:txBody>
+          <a:bodyPr wrap="square" lIns="0" tIns="0" rIns="0" bIns="0" rtlCol="0" anchor="t"/>
+          <a:lstStyle/>
+          <a:p>
+            <a:pPr indent="0" marL="0">
+              <a:buNone/>
+            </a:pPr>
+            <a:r>
+              <a:rPr lang="en-US" sz="1600" b="1" dirty="0">
+                <a:solidFill>
+                  <a:schemeClr val="tx1"/>
+                </a:solidFill>
+              </a:rPr>
+              <a:t>Beats baselines</a:t>
+            </a:r>
+            <a:endParaRPr lang="en-US" sz="1600" dirty="0"/>
+          </a:p>
+        </p:txBody>
+      </p:sp>
+      <p:sp>
+        <p:nvSpPr>
+          <p:cNvPr id="23" name="Text 20"/>
+          <p:cNvSpPr txBox="1"/>
+          <p:nvPr/>
+        </p:nvSpPr>
+        <p:spPr>
+          <a:xfrm>
+            <a:off x="4297680" y="5120640"/>
+            <a:ext cx="1965960" cy="1005840"/>
+          </a:xfrm>
+          <a:prstGeom prst="rect">
+            <a:avLst/>
+          </a:prstGeom>
+          <a:noFill/>
+          <a:ln/>
+        </p:spPr>
+        <p:txBody>
+          <a:bodyPr wrap="square" lIns="0" tIns="0" rIns="0" bIns="0" rtlCol="0" anchor="t"/>
+          <a:lstStyle/>
+          <a:p>
+            <a:pPr indent="0" marL="0">
+              <a:buNone/>
+            </a:pPr>
+            <a:r>
+              <a:rPr lang="en-US" sz="1300" dirty="0">
+                <a:solidFill>
+                  <a:schemeClr val="tx1"/>
+                </a:solidFill>
+              </a:rPr>
+              <a:t>RMSE below both baselines; ranking above popularity</a:t>
+            </a:r>
+            <a:endParaRPr lang="en-US" sz="1300" dirty="0"/>
+          </a:p>
+        </p:txBody>
+      </p:sp>
+      <p:sp>
+        <p:nvSpPr>
+          <p:cNvPr id="24" name="Shape 21"/>
+          <p:cNvSpPr/>
+          <p:nvPr/>
+        </p:nvSpPr>
+        <p:spPr>
+          <a:xfrm>
+            <a:off x="6697980" y="3886200"/>
+            <a:ext cx="2331720" cy="2331720"/>
+          </a:xfrm>
+          <a:prstGeom prst="roundRect">
+            <a:avLst>
+              <a:gd name="adj" fmla="val 3137"/>
+            </a:avLst>
+          </a:prstGeom>
+          <a:solidFill>
+            <a:schemeClr val="bg2"/>
+          </a:solidFill>
+          <a:ln/>
+        </p:spPr>
+      </p:sp>
+      <p:sp>
+        <p:nvSpPr>
+          <p:cNvPr id="25" name="Text 22"/>
+          <p:cNvSpPr txBox="1"/>
+          <p:nvPr/>
+        </p:nvSpPr>
+        <p:spPr>
+          <a:xfrm>
+            <a:off x="6880860" y="4023360"/>
+            <a:ext cx="1965960" cy="685800"/>
+          </a:xfrm>
+          <a:prstGeom prst="rect">
+            <a:avLst/>
+          </a:prstGeom>
+          <a:noFill/>
+          <a:ln/>
+        </p:spPr>
+        <p:txBody>
+          <a:bodyPr wrap="square" lIns="0" tIns="0" rIns="0" bIns="0" rtlCol="0" anchor="t"/>
+          <a:lstStyle/>
+          <a:p>
+            <a:pPr indent="0" marL="0">
+              <a:buNone/>
+            </a:pPr>
+            <a:r>
+              <a:rPr lang="en-US" sz="3600" b="1" dirty="0">
+                <a:solidFill>
+                  <a:schemeClr val="accent4"/>
+                </a:solidFill>
+              </a:rPr>
+              <a:t>4</a:t>
+            </a:r>
+            <a:endParaRPr lang="en-US" sz="3600" dirty="0"/>
+          </a:p>
+        </p:txBody>
+      </p:sp>
+      <p:sp>
+        <p:nvSpPr>
+          <p:cNvPr id="26" name="Text 23"/>
+          <p:cNvSpPr txBox="1"/>
+          <p:nvPr/>
+        </p:nvSpPr>
+        <p:spPr>
+          <a:xfrm>
+            <a:off x="6880860" y="4709160"/>
+            <a:ext cx="1965960" cy="411480"/>
+          </a:xfrm>
+          <a:prstGeom prst="rect">
+            <a:avLst/>
+          </a:prstGeom>
+          <a:noFill/>
+          <a:ln/>
+        </p:spPr>
+        <p:txBody>
+          <a:bodyPr wrap="square" lIns="0" tIns="0" rIns="0" bIns="0" rtlCol="0" anchor="t"/>
+          <a:lstStyle/>
+          <a:p>
+            <a:pPr indent="0" marL="0">
+              <a:buNone/>
+            </a:pPr>
+            <a:r>
+              <a:rPr lang="en-US" sz="1600" b="1" dirty="0">
+                <a:solidFill>
+                  <a:schemeClr val="tx1"/>
+                </a:solidFill>
+              </a:rPr>
+              <a:t>Recommendations</a:t>
+            </a:r>
+            <a:endParaRPr lang="en-US" sz="1600" dirty="0"/>
+          </a:p>
+        </p:txBody>
+      </p:sp>
+      <p:sp>
+        <p:nvSpPr>
+          <p:cNvPr id="27" name="Text 24"/>
+          <p:cNvSpPr txBox="1"/>
+          <p:nvPr/>
+        </p:nvSpPr>
+        <p:spPr>
+          <a:xfrm>
+            <a:off x="6880860" y="5120640"/>
+            <a:ext cx="1965960" cy="1005840"/>
+          </a:xfrm>
+          <a:prstGeom prst="rect">
+            <a:avLst/>
+          </a:prstGeom>
+          <a:noFill/>
+          <a:ln/>
+        </p:spPr>
+        <p:txBody>
+          <a:bodyPr wrap="square" lIns="0" tIns="0" rIns="0" bIns="0" rtlCol="0" anchor="t"/>
+          <a:lstStyle/>
+          <a:p>
+            <a:pPr indent="0" marL="0">
+              <a:buNone/>
+            </a:pPr>
+            <a:r>
+              <a:rPr lang="en-US" sz="1300" dirty="0">
+                <a:solidFill>
+                  <a:schemeClr val="tx1"/>
+                </a:solidFill>
+              </a:rPr>
+              <a:t>10 unique, unseen, each with ≥ 20 ratings</a:t>
+            </a:r>
+            <a:endParaRPr lang="en-US" sz="1300" dirty="0"/>
+          </a:p>
+        </p:txBody>
+      </p:sp>
+      <p:sp>
+        <p:nvSpPr>
+          <p:cNvPr id="28" name="Shape 25"/>
+          <p:cNvSpPr/>
+          <p:nvPr/>
+        </p:nvSpPr>
+        <p:spPr>
+          <a:xfrm>
+            <a:off x="9281160" y="3886200"/>
+            <a:ext cx="2331720" cy="2331720"/>
+          </a:xfrm>
+          <a:prstGeom prst="roundRect">
+            <a:avLst>
+              <a:gd name="adj" fmla="val 3137"/>
+            </a:avLst>
+          </a:prstGeom>
+          <a:solidFill>
+            <a:schemeClr val="bg2"/>
+          </a:solidFill>
+          <a:ln/>
+        </p:spPr>
+      </p:sp>
+      <p:sp>
+        <p:nvSpPr>
+          <p:cNvPr id="29" name="Text 26"/>
+          <p:cNvSpPr txBox="1"/>
+          <p:nvPr/>
+        </p:nvSpPr>
+        <p:spPr>
+          <a:xfrm>
+            <a:off x="9464040" y="4023360"/>
+            <a:ext cx="1965960" cy="685800"/>
+          </a:xfrm>
+          <a:prstGeom prst="rect">
+            <a:avLst/>
+          </a:prstGeom>
+          <a:noFill/>
+          <a:ln/>
+        </p:spPr>
+        <p:txBody>
+          <a:bodyPr wrap="square" lIns="0" tIns="0" rIns="0" bIns="0" rtlCol="0" anchor="t"/>
+          <a:lstStyle/>
+          <a:p>
+            <a:pPr indent="0" marL="0">
+              <a:buNone/>
+            </a:pPr>
+            <a:r>
+              <a:rPr lang="en-US" sz="3600" b="1" dirty="0">
+                <a:solidFill>
+                  <a:schemeClr val="accent4"/>
+                </a:solidFill>
+              </a:rPr>
+              <a:t>2</a:t>
+            </a:r>
+            <a:endParaRPr lang="en-US" sz="3600" dirty="0"/>
+          </a:p>
+        </p:txBody>
+      </p:sp>
+      <p:sp>
+        <p:nvSpPr>
+          <p:cNvPr id="30" name="Text 27"/>
+          <p:cNvSpPr txBox="1"/>
+          <p:nvPr/>
+        </p:nvSpPr>
+        <p:spPr>
+          <a:xfrm>
+            <a:off x="9464040" y="4709160"/>
+            <a:ext cx="1965960" cy="411480"/>
+          </a:xfrm>
+          <a:prstGeom prst="rect">
+            <a:avLst/>
+          </a:prstGeom>
+          <a:noFill/>
+          <a:ln/>
+        </p:spPr>
+        <p:txBody>
+          <a:bodyPr wrap="square" lIns="0" tIns="0" rIns="0" bIns="0" rtlCol="0" anchor="t"/>
+          <a:lstStyle/>
+          <a:p>
+            <a:pPr indent="0" marL="0">
+              <a:buNone/>
+            </a:pPr>
+            <a:r>
+              <a:rPr lang="en-US" sz="1600" b="1" dirty="0">
+                <a:solidFill>
+                  <a:schemeClr val="tx1"/>
+                </a:solidFill>
+              </a:rPr>
+              <a:t>Scalability trends</a:t>
+            </a:r>
+            <a:endParaRPr lang="en-US" sz="1600" dirty="0"/>
+          </a:p>
+        </p:txBody>
+      </p:sp>
+      <p:sp>
+        <p:nvSpPr>
+          <p:cNvPr id="31" name="Text 28"/>
+          <p:cNvSpPr txBox="1"/>
+          <p:nvPr/>
+        </p:nvSpPr>
+        <p:spPr>
+          <a:xfrm>
+            <a:off x="9464040" y="5120640"/>
+            <a:ext cx="1965960" cy="1005840"/>
+          </a:xfrm>
+          <a:prstGeom prst="rect">
+            <a:avLst/>
+          </a:prstGeom>
+          <a:noFill/>
+          <a:ln/>
+        </p:spPr>
+        <p:txBody>
+          <a:bodyPr wrap="square" lIns="0" tIns="0" rIns="0" bIns="0" rtlCol="0" anchor="t"/>
+          <a:lstStyle/>
+          <a:p>
+            <a:pPr indent="0" marL="0">
+              <a:buNone/>
+            </a:pPr>
+            <a:r>
+              <a:rPr lang="en-US" sz="1300" dirty="0">
+                <a:solidFill>
+                  <a:schemeClr val="tx1"/>
+                </a:solidFill>
+              </a:rPr>
+              <a:t>more cores → faster ALS; more data → lower RMSE</a:t>
+            </a:r>
+            <a:endParaRPr lang="en-US" sz="1300" dirty="0"/>
+          </a:p>
+        </p:txBody>
+      </p:sp>
+      <p:sp>
+        <p:nvSpPr>
+          <p:cNvPr id="25" name="Slide Number Placeholder 0"/>
+          <p:cNvSpPr>
+            <a:spLocks noGrp="1"/>
+          </p:cNvSpPr>
+          <p:nvPr>
+            <p:ph type="sldNum" sz="quarter" idx="4294967295"/>
+          </p:nvPr>
+        </p:nvSpPr>
+        <p:spPr>
+          <a:xfrm>
+            <a:off x="11155680" y="6400800"/>
+            <a:ext cx="457200" cy="274320"/>
+          </a:xfrm>
+          <a:prstGeom prst="rect">
+            <a:avLst/>
+          </a:prstGeom>
+          <a:extLst>
+            <a:ext uri="{C572A759-6A51-4108-AA02-DFA0A04FC94B}">
+              <ma14:wrappingTextBoxFlag xmlns:ma14="http://schemas.microsoft.com/office/mac/drawingml/2011/main" val="0"/>
+            </a:ext>
+          </a:extLst>
+        </p:spPr>
+        <p:txBody>
+          <a:bodyPr/>
+          <a:lstStyle>
+            <a:lvl1pPr>
+              <a:defRPr sz="1000">
+                <a:solidFill>
+                  <a:srgbClr val="8D99AE"/>
+                </a:solidFill>
+              </a:defRPr>
+            </a:lvl1pPr>
+          </a:lstStyle>
+          <a:p>
+            <a:pPr algn="r"/>
+            <a:fld id="{F7021451-1387-4CA6-816F-3879F97B5CBC}" type="slidenum">
+              <a:rPr b="0" lang="en-US"/>
+              <a:t>21</a:t>
+            </a:fld>
+            <a:endParaRPr lang="en-US"/>
+          </a:p>
+        </p:txBody>
+      </p:sp>
+    </p:spTree>
+  </p:cSld>
+  <p:clrMapOvr>
+    <a:masterClrMapping/>
+  </p:clrMapOvr>
+</p:sld>
+</file>
+
+<file path=ppt/slides/slide22.xml><?xml version="1.0" encoding="utf-8"?>
+<p:sld xmlns:a="http://schemas.openxmlformats.org/drawingml/2006/main" xmlns:r="http://schemas.openxmlformats.org/officeDocument/2006/relationships" xmlns:p="http://schemas.openxmlformats.org/presentationml/2006/main">
+  <p:cSld name="Slide 22">
+    <p:spTree>
+      <p:nvGrpSpPr>
+        <p:cNvPr id="1" name=""/>
+        <p:cNvGrpSpPr/>
+        <p:nvPr/>
+      </p:nvGrpSpPr>
+      <p:grpSpPr>
+        <a:xfrm>
+          <a:off x="0" y="0"/>
+          <a:ext cx="0" cy="0"/>
+          <a:chOff x="0" y="0"/>
+          <a:chExt cx="0" cy="0"/>
+        </a:xfrm>
+      </p:grpSpPr>
+      <p:sp>
+        <p:nvSpPr>
+          <p:cNvPr id="2" name="Text 0"/>
+          <p:cNvSpPr/>
+          <p:nvPr>
+            <p:ph idx="100" type="title" hasCustomPrompt="1"/>
+          </p:nvPr>
+        </p:nvSpPr>
+        <p:spPr>
+          <a:xfrm>
+            <a:off x="548640" y="320040"/>
+            <a:ext cx="11064240" cy="777240"/>
+          </a:xfrm>
+          <a:prstGeom prst="rect">
+            <a:avLst/>
+          </a:prstGeom>
+          <a:noFill/>
+          <a:ln/>
+        </p:spPr>
+        <p:txBody>
+          <a:bodyPr wrap="square" lIns="0" tIns="0" rIns="0" bIns="0" rtlCol="0" anchor="ctr"/>
+          <a:lstStyle/>
+          <a:p>
+            <a:pPr indent="0" marL="0">
+              <a:buNone/>
+            </a:pPr>
+            <a:r>
+              <a:rPr lang="en-US" sz="3600" b="1" dirty="0">
+                <a:solidFill>
+                  <a:schemeClr val="tx1"/>
+                </a:solidFill>
+              </a:rPr>
+              <a:t>Challenges and solutions</a:t>
+            </a:r>
+            <a:endParaRPr lang="en-US" sz="3600" dirty="0"/>
+          </a:p>
+        </p:txBody>
+      </p:sp>
+      <p:graphicFrame>
+        <p:nvGraphicFramePr>
+          <p:cNvPr id="23" name="Table 0"/>
           <p:cNvGraphicFramePr>
             <a:graphicFrameLocks noGrp="1"/>
           </p:cNvGraphicFramePr>
@@ -15935,7 +16778,7 @@
             <a:pPr algn="r"/>
             <a:fld id="{F7021451-1387-4CA6-816F-3879F97B5CBC}" type="slidenum">
               <a:rPr b="0" lang="en-US"/>
-              <a:t>20</a:t>
+              <a:t>22</a:t>
             </a:fld>
             <a:endParaRPr lang="en-US"/>
           </a:p>
@@ -15949,9 +16792,9 @@
 </p:sld>
 </file>
 
-<file path=ppt/slides/slide21.xml><?xml version="1.0" encoding="utf-8"?>
+<file path=ppt/slides/slide23.xml><?xml version="1.0" encoding="utf-8"?>
 <p:sld xmlns:a="http://schemas.openxmlformats.org/drawingml/2006/main" xmlns:r="http://schemas.openxmlformats.org/officeDocument/2006/relationships" xmlns:p="http://schemas.openxmlformats.org/presentationml/2006/main">
-  <p:cSld name="Slide 21">
+  <p:cSld name="Slide 23">
     <p:spTree>
       <p:nvGrpSpPr>
         <p:cNvPr id="1" name=""/>
@@ -16501,7 +17344,7 @@
         <p:spPr>
           <a:xfrm>
             <a:off x="548640" y="6080760"/>
-            <a:ext cx="11064240" cy="411480"/>
+            <a:ext cx="4114800" cy="411480"/>
           </a:xfrm>
           <a:prstGeom prst="rect">
             <a:avLst/>
@@ -16525,6 +17368,42 @@
               <a:t>Thank you · Questions?</a:t>
             </a:r>
             <a:endParaRPr lang="en-US" sz="1800" dirty="0"/>
+          </a:p>
+        </p:txBody>
+      </p:sp>
+      <p:sp>
+        <p:nvSpPr>
+          <p:cNvPr id="19" name="Text 16"/>
+          <p:cNvSpPr txBox="1"/>
+          <p:nvPr/>
+        </p:nvSpPr>
+        <p:spPr>
+          <a:xfrm>
+            <a:off x="5669280" y="6080760"/>
+            <a:ext cx="5943600" cy="411480"/>
+          </a:xfrm>
+          <a:prstGeom prst="rect">
+            <a:avLst/>
+          </a:prstGeom>
+          <a:noFill/>
+          <a:ln/>
+        </p:spPr>
+        <p:txBody>
+          <a:bodyPr wrap="square" lIns="0" tIns="0" rIns="0" bIns="0" rtlCol="0" anchor="t"/>
+          <a:lstStyle/>
+          <a:p>
+            <a:pPr algn="r" indent="0" marL="0">
+              <a:buNone/>
+            </a:pPr>
+            <a:r>
+              <a:rPr lang="en-US" sz="1400" dirty="0">
+                <a:solidFill>
+                  <a:schemeClr val="accent5"/>
+                </a:solidFill>
+              </a:rPr>
+              <a:t>Live: movie-recommendation-spark.onrender.com</a:t>
+            </a:r>
+            <a:endParaRPr lang="en-US" sz="1400" dirty="0"/>
           </a:p>
         </p:txBody>
       </p:sp>

</xml_diff>